<commit_message>
Replace carob with Chinese hibiscus in botany presentation, embed user photo
Co-Authored-By: Claude Fable 5 <noreply@anthropic.com>
Claude-Session: https://claude.ai/code/session_01MZ4UbxGnn8qpC5Lqb74Zf6
</commit_message>
<xml_diff>
--- a/presentation/botany-video-presentation.pptx
+++ b/presentation/botany-video-presentation.pptx
@@ -516,7 +516,7 @@
           <a:p>
             <a:r>
               <a:rPr lang="en-US" dirty="0"/>
-              <a:t>פתיחה לסרטון (כ-20 שניות): שלום, בסרטון הזה אציג שני עצים נפוצים באזור מגוריי, אורן ירושלים וחרוב מצוי. כל אחד מהם שייך לקבוצה אחרת של צמחים בעלי זרעים: האורן לחשופי הזרע והחרוב למכוסי הזרע. דרך שני העצים אראה איך שתי הקבוצות פותרות את אותן בעיות, רבייה והפצה ביבשה, בדרכים שונות לגמרי. [להשלים: שם מלא ות.ז. בשקף]</a:t>
+              <a:t>פתיחה לסרטון (כ-20 שניות): שלום, בסרטון הזה אציג שני צמחים רב-שנתיים מאזור מגוריי, עץ אורן ירושלים ושיח היביסקוס סיני. כל אחד מהם שייך לקבוצה אחרת של צמחים בעלי זרעים: האורן לחשופי הזרע וההיביסקוס למכוסי הזרע. דרך שניהם אראה איך שתי הקבוצות פותרות את אותן בעיות, רבייה והפצה ביבשה, בדרכים שונות לגמרי. [להשלים: שם מלא ות.ז. בשקף]</a:t>
             </a:r>
             <a:endParaRPr lang="en-US" dirty="0"/>
           </a:p>
@@ -604,7 +604,7 @@
           <a:p>
             <a:r>
               <a:rPr lang="en-US" dirty="0"/>
-              <a:t>חרוב, תפוצה (כ-30 שניות): התפוצה הטבעית של החרוב היא סביב הים התיכון, בעיקר בחלקו המזרחי, ובישראל הוא מרכיב בולט בחורש בשפלה ובהרים הנמוכים. בעזרת האדם הוא הגיע רחוק: הוא מתורבת אלפי שנים בזכות התרמילים המתוקים, וניטע היום גם ברחובות ובגינות. כך ששוב, כמו אצל האורן, האדם הרחיב מאוד את התפוצה.</a:t>
+              <a:t>היביסקוס, תפוצה (כ-30 שניות): כאן ההבדל מהאורן מעניין במיוחד. מוצא ההיביסקוס הסיני באזורים הטרופיים של מזרח אסיה, אבל הוא מתורבת כל כך הרבה זמן שכמעט לא מכירים אוכלוסיות בר ודאיות שלו. את כל תפוצתו הנוכחית עשה בעזרת האדם: הוא ניטע כצמח נוי באזורים חמים בכל העולם, ובישראל כל שיח היביסקוס שנראה ברחוב או בגינה ניטע בידי אדם. אצל האורן האדם הרחיב תפוצה טבעית קיימת; אצל ההיביסקוס האדם הוא כמעט כל הסיפור.</a:t>
             </a:r>
             <a:endParaRPr lang="en-US" dirty="0"/>
           </a:p>
@@ -692,7 +692,7 @@
           <a:p>
             <a:r>
               <a:rPr lang="en-US" dirty="0"/>
-              <a:t>חרוב, האבקה והפצה (כ-40 שניות): כאן ההבדל מהאורן חד. החרוב פורח דווקא בסתיו, והתפרחות שלו מדיפות ריח חזק שמושך זבובים ודבורים; הם המאביקים העיקריים שמעבירים אבקה מעצי הזכר לעצי הנקבה. ההפצה נעשית דרך הפרי: התרמיל המתוק מושך שועלים, תנים, מכרסמים ובהמות בית. הם אוכלים את הציפה, והזרעים הקשים עוברים את מערכת העיכול בשלום ומופרשים רחוק מעץ האם. העץ בעצם משלם בפרי תמורת שירותי משלוח.</a:t>
+              <a:t>היביסקוס, האבקה והפצה (כ-40 שניות): בניגוד לאורן, ההיביסקוס בנוי כולו סביב בעלי חיים. הפרח הגדול והאדום מציע צוף, ובאזורי המוצא הטרופיים מאביקים אותו בעיקר ציפורים צופיות ופרפרים. גם אצלנו אפשר לראות את הצופית הבוהקת מבקרת בפרחים, ולידה דבורים. לגבי ההפצה: הפרי של ההיביסקוס הוא הלקט שנפתח כשהוא מבשיל, אבל רוב זני התרבות כמעט אינם חונטים פרי, ולכן בפועל מי שמפיץ את הצמח הוא האדם, באמצעות ייחורים ושתילה. זו נקודה מעניינת: אצל צמח תרבות, האדם תופס את מקומם של סוכני ההפצה הטבעיים. [לצלם את הפרח מקרוב, ואם יש מזל גם צופית או דבורה]</a:t>
             </a:r>
             <a:endParaRPr lang="en-US" dirty="0"/>
           </a:p>
@@ -780,7 +780,7 @@
           <a:p>
             <a:r>
               <a:rPr lang="en-US" dirty="0"/>
-              <a:t>השוואה (כ-40 שניות): נסכם את ההבדלים זה מול זה. האורן, חשוף זרע ממשפחת האורניים, מסתמך כולו על הרוח: גם להאבקה וגם להפצת הזרעים בעלי הכנפית, ואפילו נעזר בשריפות להתחדשות. החרוב, מכוסה זרע ממשפחת הקטניות, מגייס בעלי חיים לשני השלבים: חרקים מאביקים את פרחיו בסתיו, ויונקים מפיצים את זרעיו דרך התרמיל המתוק. אותן שתי משימות בדיוק, האבקה והפצה, ושתי אסטרטגיות הפוכות.</a:t>
+              <a:t>השוואה (כ-40 שניות): נסכם את ההבדלים זה מול זה. האורן, חשוף זרע ממשפחת האורניים, הוא עץ שמסתמך כולו על הרוח: גם להאבקה וגם להפצת הזרעים בעלי הכנפית, ואפילו נעזר בשריפות להתחדשות. ההיביסקוס, מכוסה זרע ממשפחת החלמיתיים, הוא שיח שפרחיו הגדולים מגייסים בעלי חיים להאבקה, ציפורים צופיות ופרפרים, ובתור צמח תרבות את ההפצה שלו עושה בעיקר האדם. אותן שתי משימות בדיוק, האבקה והפצה, ושתי אסטרטגיות שונות לגמרי.</a:t>
             </a:r>
             <a:endParaRPr lang="en-US" dirty="0"/>
           </a:p>
@@ -868,7 +868,7 @@
           <a:p>
             <a:r>
               <a:rPr lang="en-US" dirty="0"/>
-              <a:t>נושאי רשות (כ-30 שניות): שתי תוספות מעניינות. הראשונה, פנולוגיה: לשני העצים לוח שנה כמעט הפוך. האורן מאביק באביב ומפזר זרעים בקיץ, והחרוב פורח דווקא בסתיו והתרמילים שלו מבשילים רק בקיץ שאחרי. השנייה, הקשר לאדם: מזרעי החרוב האחידים נגזרה יחידת הקראט של אבני החן, והאורן הוא העץ שמעצב את נוף היערות הנטועים של ישראל. [אפשר להחליף בנושא רשות אחר או להוסיף קשר אישי שלכם לעצים]</a:t>
+              <a:t>נושאי רשות (כ-30 שניות): שתי תוספות מעניינות. הראשונה, פנולוגיה: האורן מרוכז, אבקה באביב וזרעים בקיץ, ואילו ההיביסקוס פורח כמעט כל השנה, אבל כל פרח בודד חי יום או יומיים בלבד. השנייה, הקשר לאדם: ההיביסקוס הסיני הוא מצמחי הנוי הנפוצים בעולם והפרח הלאומי של מלזיה, ושמו המדעי פירושו 'ורד סיני'. האורן, מצדו, הוא העץ שמעצב את נוף היערות הנטועים של ישראל. [אפשר להחליף בנושא רשות אחר או להוסיף קשר אישי שלכם לצמחים]</a:t>
             </a:r>
             <a:endParaRPr lang="en-US" dirty="0"/>
           </a:p>
@@ -956,7 +956,7 @@
           <a:p>
             <a:r>
               <a:rPr lang="en-US" dirty="0"/>
-              <a:t>סיכום לסרטון (כ-25 שניות): ראינו שני עצים שגדלים לעיתים באותו חורש ממש, ובכל זאת מייצגים שתי קבוצות שונות של צמחים בעלי זרעים. האורן, חשוף הזרע, בנה את כל מחזור החיים שלו על הרוח. החרוב, מכוסה הזרע, קשר את גורלו בבעלי חיים, מהזבוב המאביק ועד השועל שמפיץ את זרעיו. תודה על הצפייה.</a:t>
+              <a:t>סיכום לסרטון (כ-25 שניות): ראינו שני צמחים שגדלים זה לצד זה בשכונה, ובכל זאת מייצגים שתי קבוצות שונות של צמחים בעלי זרעים. האורן, חשוף הזרע, בנה את כל מחזור החיים שלו על הרוח, בלי פרח ובלי פרי. ההיביסקוס, מכוסה הזרע, שם הכול על הפרח: צבע, צוף ומבנה שמושכים בעלי חיים, וכצמח תרבות הוא גייס להפצתו את המפיץ היעיל מכולם, האדם. תודה על הצפייה.</a:t>
             </a:r>
             <a:endParaRPr lang="en-US" dirty="0"/>
           </a:p>
@@ -1132,7 +1132,7 @@
           <a:p>
             <a:r>
               <a:rPr lang="en-US" dirty="0"/>
-              <a:t>מבנה הסרטון (כ-20 שניות): לכל עץ אעבור על ששת הנושאים שנדרשו במטלה: מיון סיסטמתי, התכונות שמשייכות אותו לקבוצתו, צורת החיים, התפוצה הטבעית והנוכחית, צורת ההאבקה ואופן הפצת הזרעים. בסוף אשווה בין השניים ואוסיף שני נושאי רשות: פנולוגיה והקשר לאדם.</a:t>
+              <a:t>מבנה הסרטון (כ-20 שניות): לכל עץ אעבור על ששת הנושאים שנדרשו במטלה: מיון סיסטמתי, התכונות שמשייכות אותו לקבוצתו, צורת החיים, התפוצה הטבעית והנוכחית, צורת ההאבקה ואופן הפצת הזרעים. בסוף אשווה בין השניים ואוסיף שני נושאי רשות: פנולוגיה והקשר לאדם. (הנוסח בשקף מדבר על 'כל צמח'; אצלי אלה עץ אחד ושיח אחד, ושניהם רב-שנתיים כפי שהמטלה דורשת.)</a:t>
             </a:r>
             <a:endParaRPr lang="en-US" dirty="0"/>
           </a:p>
@@ -1220,7 +1220,7 @@
           <a:p>
             <a:r>
               <a:rPr lang="en-US" dirty="0"/>
-              <a:t>רקע מהקורס (כ-30 שניות): שתי הקבוצות שייכות לצמחים בעלי הזרעים. אצל שתיהן השלב הדומיננטי במחזור החיים הוא הספורופיט הדיפלואידי, ולשתיהן התאמות מבניות ליבשה: קוטיקולה, פיוניות ורקמות הובלה. ההבדל הגדול הוא באיברי הרבייה: חשופי הזרע מייצרים אבקה וזרעים באצטרובלים, בלי פרח ובלי פרי, ואילו אצל מכוסי הזרע הפרח הוא איבר הרבייה והזרע מתפתח בתוך פרי. שני העצים שבחרתי מדגימים בדיוק את ההבדל הזה.</a:t>
+              <a:t>רקע מהקורס (כ-30 שניות): שתי הקבוצות שייכות לצמחים בעלי הזרעים. אצל שתיהן השלב הדומיננטי במחזור החיים הוא הספורופיט הדיפלואידי, ולשתיהן התאמות מבניות ליבשה: קוטיקולה, פיוניות ורקמות הובלה. ההבדל הגדול הוא באיברי הרבייה: חשופי הזרע מייצרים אבקה וזרעים באצטרובלים, בלי פרח ובלי פרי, ואילו אצל מכוסי הזרע הפרח הוא איבר הרבייה והזרע מתפתח בתוך פרי. שני הצמחים שבחרתי מדגימים בדיוק את ההבדל הזה.</a:t>
             </a:r>
             <a:endParaRPr lang="en-US" dirty="0"/>
           </a:p>
@@ -1660,7 +1660,7 @@
           <a:p>
             <a:r>
               <a:rPr lang="en-US" dirty="0"/>
-              <a:t>חרוב, מיון (כ-25 שניות): העץ השני הוא חרוב מצוי. הוא שייך לממלכת הצמחים, לקבוצת מכוסי הזרע ובתוכה לדו-פסיגיים, למשפחת הקטניות, לסוג חרוב ולמין חרוב מצוי, Ceratonia siliqua. גם כאן, מין מסוים ולא רק 'חרוב'. [צלמו את עצמכם ליד עץ חרוב באזור המגורים]</a:t>
+              <a:t>היביסקוס, מיון (כ-25 שניות): הצמח השני הוא היביסקוס סיני, השיח שצילמתי ליד הבית. הוא שייך לממלכת הצמחים, לקבוצת מכוסי הזרע ובתוכה לדו-פסיגיים, למשפחת החלמיתיים, לסוג היביסקוס ולמין היביסקוס סיני, Hibiscus rosa-sinensis. גם כאן, מין מסוים ולא רק 'היביסקוס'. [מומלץ לצלם את עצמכם מדברים ליד השיח]</a:t>
             </a:r>
             <a:endParaRPr lang="en-US" dirty="0"/>
           </a:p>
@@ -1748,7 +1748,7 @@
           <a:p>
             <a:r>
               <a:rPr lang="en-US" dirty="0"/>
-              <a:t>חרוב, שיוך וצורת חיים (כ-40 שניות): החרוב מדגים את תכונות מכוסי הזרע: יש לו פרחים, גם אם קטנים ולא מרשימים, והזרעים שלו מתפתחים בתוך פרי, תרמיל חום שמוכר לכולנו. זו בדיוק המשמעות של 'מכוסה זרע', הזרע עטוף ומוגן. צורת החיים: עץ ירוק-עד בגובה חמישה עד עשרה מטרים, עם עלים מנוצים קשים ומבריקים. החרוב לרוב דו-ביתי: יש עצי זכר ועצי נקבה, ורק הנקבות נושאות פרי. [כדאי להראות עלה, תפרחת אם העונה מתאימה, ותרמיל]</a:t>
+              <a:t>היביסקוס, שיוך וצורת חיים (כ-40 שניות): ההיביסקוס מדגים את מכוסי הזרע בצורה הכי ברורה שיש: פרח גדול ואדום, עם חמישה עלי כותרת ועמוד מרכזי בולט שנושא את האבקנים ואת הצלקות, מבנה אופייני למשפחת החלמיתיים. הביצית סגורה בתוך שחלה, ואחרי הפריה הזרעים מתפתחים בתוך פרי. צורת החיים שונה מהאורן: זה שיח, לא עץ. הוא מסתעף כבר מהבסיס, בלי גזע מרכזי, ומגיע בדרך כלל לגובה של מטר עד שלושה מטרים. [להראות את הפרח מקרוב מול המצלמה, לפתוח ולהצביע על האבקנים והצלקת]</a:t>
             </a:r>
             <a:endParaRPr lang="en-US" dirty="0"/>
           </a:p>
@@ -2180,7 +2180,7 @@
             <a:avLst/>
           </a:prstGeom>
           <a:solidFill>
-            <a:srgbClr val="8A5A2B"/>
+            <a:srgbClr val="A8353A"/>
           </a:solidFill>
           <a:ln/>
         </p:spPr>
@@ -2309,7 +2309,7 @@
                 <a:ea typeface="Arial" pitchFamily="34" charset="-122"/>
                 <a:cs typeface="Arial" pitchFamily="34" charset="-120"/>
               </a:rPr>
-              <a:t> מול חרוב מצוי </a:t>
+              <a:t> מול היביסקוס סיני </a:t>
             </a:r>
             <a:pPr algn="ctr" indent="0" marL="0">
               <a:buNone/>
@@ -2323,7 +2323,7 @@
                 <a:ea typeface="Times New Roman" pitchFamily="34" charset="-122"/>
                 <a:cs typeface="Times New Roman" pitchFamily="34" charset="-120"/>
               </a:rPr>
-              <a:t>(Ceratonia siliqua)</a:t>
+              <a:t>(Hibiscus rosa-sinensis)</a:t>
             </a:r>
             <a:endParaRPr lang="en-US" sz="2100" dirty="0"/>
           </a:p>
@@ -2362,7 +2362,7 @@
                 <a:ea typeface="Arial" pitchFamily="34" charset="-122"/>
                 <a:cs typeface="Arial" pitchFamily="34" charset="-120"/>
               </a:rPr>
-              <a:t>שני עצים משתי קבוצות: חשופי זרע ומכוסי זרע</a:t>
+              <a:t>עץ ושיח משתי קבוצות: חשופי זרע ומכוסי זרע</a:t>
             </a:r>
             <a:endParaRPr lang="en-US" sz="1600" dirty="0"/>
           </a:p>
@@ -2499,7 +2499,7 @@
             </a:avLst>
           </a:prstGeom>
           <a:solidFill>
-            <a:srgbClr val="8A5A2B"/>
+            <a:srgbClr val="A8353A"/>
           </a:solidFill>
           <a:ln/>
         </p:spPr>
@@ -2537,7 +2537,7 @@
                 <a:ea typeface="Arial" pitchFamily="34" charset="-122"/>
                 <a:cs typeface="Arial" pitchFamily="34" charset="-120"/>
               </a:rPr>
-              <a:t>העץ השני · מכוסה זרע</a:t>
+              <a:t>הצמח השני · מכוסה זרע</a:t>
             </a:r>
             <a:endParaRPr lang="en-US" sz="1250" dirty="0"/>
           </a:p>
@@ -2570,13 +2570,13 @@
             <a:r>
               <a:rPr lang="en-US" sz="2600" b="1" dirty="0">
                 <a:solidFill>
-                  <a:srgbClr val="8A5A2B"/>
-                </a:solidFill>
-                <a:latin typeface="Arial" pitchFamily="34" charset="0"/>
-                <a:ea typeface="Arial" pitchFamily="34" charset="-122"/>
-                <a:cs typeface="Arial" pitchFamily="34" charset="-120"/>
-              </a:rPr>
-              <a:t>חרוב מצוי: תפוצה טבעית ונוכחית</a:t>
+                  <a:srgbClr val="A8353A"/>
+                </a:solidFill>
+                <a:latin typeface="Arial" pitchFamily="34" charset="0"/>
+                <a:ea typeface="Arial" pitchFamily="34" charset="-122"/>
+                <a:cs typeface="Arial" pitchFamily="34" charset="-120"/>
+              </a:rPr>
+              <a:t>היביסקוס סיני: תפוצה טבעית ונוכחית</a:t>
             </a:r>
             <a:endParaRPr lang="en-US" sz="2600" dirty="0"/>
           </a:p>
@@ -2788,7 +2788,7 @@
                 <a:ea typeface="Arial" pitchFamily="34" charset="-122"/>
                 <a:cs typeface="Arial" pitchFamily="34" charset="-120"/>
               </a:rPr>
-              <a:t>אגן הים התיכון, ובעיקר חלקו המזרחי</a:t>
+              <a:t>מוצאו באזורים הטרופיים של מזרח אסיה</a:t>
             </a:r>
             <a:endParaRPr lang="en-US" sz="1450" dirty="0"/>
           </a:p>
@@ -2812,7 +2812,7 @@
                 <a:ea typeface="Arial" pitchFamily="34" charset="-122"/>
                 <a:cs typeface="Arial" pitchFamily="34" charset="-120"/>
               </a:rPr>
-              <a:t>בישראל: מרכיב בולט בחורש הים-תיכוני בשפלה, בהרים הנמוכים ובצפון הנגב</a:t>
+              <a:t>מוכר בעיקר כצמח תרבות עתיק, עד כדי כך שאוכלוסיות בר ודאיות שלו כמעט אינן ידועות</a:t>
             </a:r>
             <a:endParaRPr lang="en-US" sz="1450" dirty="0"/>
           </a:p>
@@ -2835,7 +2835,7 @@
             </a:avLst>
           </a:prstGeom>
           <a:solidFill>
-            <a:srgbClr val="F5EDE1"/>
+            <a:srgbClr val="F8EAE8"/>
           </a:solidFill>
           <a:ln/>
         </p:spPr>
@@ -2911,7 +2911,7 @@
             <a:r>
               <a:rPr lang="en-US" sz="1600" b="1" dirty="0">
                 <a:solidFill>
-                  <a:srgbClr val="8A5A2B"/>
+                  <a:srgbClr val="A8353A"/>
                 </a:solidFill>
                 <a:latin typeface="Arial" pitchFamily="34" charset="0"/>
                 <a:ea typeface="Arial" pitchFamily="34" charset="-122"/>
@@ -2963,7 +2963,7 @@
                 <a:ea typeface="Arial" pitchFamily="34" charset="-122"/>
                 <a:cs typeface="Arial" pitchFamily="34" charset="-120"/>
               </a:rPr>
-              <a:t>מתורבת אלפי שנים סביב הים התיכון בזכות פירותיו המתוקים</a:t>
+              <a:t>צמח נוי נפוץ באזורים חמים בכל העולם, מהטרופים ועד אגן הים התיכון</a:t>
             </a:r>
             <a:endParaRPr lang="en-US" sz="1450" dirty="0"/>
           </a:p>
@@ -2987,7 +2987,7 @@
                 <a:ea typeface="Arial" pitchFamily="34" charset="-122"/>
                 <a:cs typeface="Arial" pitchFamily="34" charset="-120"/>
               </a:rPr>
-              <a:t>ניטע רבות בישראל בחורשות, בשדרות רחוב ובגינון</a:t>
+              <a:t>בישראל אינו גדל בר: כל השיחים ניטעו בגינות, בגדרות חיות וברחובות</a:t>
             </a:r>
             <a:endParaRPr lang="en-US" sz="1450" dirty="0"/>
           </a:p>
@@ -3077,7 +3077,7 @@
                 <a:ea typeface="Arial" pitchFamily="34" charset="-122"/>
                 <a:cs typeface="Arial" pitchFamily="34" charset="-120"/>
               </a:rPr>
-              <a:t>כאן צילום שלכם: העץ בסביבתו</a:t>
+              <a:t>כאן צילום שלכם: השיח בסביבתו</a:t>
             </a:r>
             <a:endParaRPr lang="en-US" sz="1150" dirty="0"/>
           </a:p>
@@ -3094,7 +3094,7 @@
                 <a:ea typeface="Arial" pitchFamily="34" charset="-122"/>
                 <a:cs typeface="Arial" pitchFamily="34" charset="-120"/>
               </a:rPr>
-              <a:t>(חורש, שדרה או גינה ציבורית)</a:t>
+              <a:t>(גינה, גדר חיה או רחוב)</a:t>
             </a:r>
             <a:endParaRPr lang="en-US" sz="1150" dirty="0"/>
           </a:p>
@@ -3149,7 +3149,7 @@
             </a:avLst>
           </a:prstGeom>
           <a:solidFill>
-            <a:srgbClr val="8A5A2B"/>
+            <a:srgbClr val="A8353A"/>
           </a:solidFill>
           <a:ln/>
         </p:spPr>
@@ -3187,7 +3187,7 @@
                 <a:ea typeface="Arial" pitchFamily="34" charset="-122"/>
                 <a:cs typeface="Arial" pitchFamily="34" charset="-120"/>
               </a:rPr>
-              <a:t>העץ השני · מכוסה זרע</a:t>
+              <a:t>הצמח השני · מכוסה זרע</a:t>
             </a:r>
             <a:endParaRPr lang="en-US" sz="1250" dirty="0"/>
           </a:p>
@@ -3220,13 +3220,13 @@
             <a:r>
               <a:rPr lang="en-US" sz="2600" b="1" dirty="0">
                 <a:solidFill>
-                  <a:srgbClr val="8A5A2B"/>
-                </a:solidFill>
-                <a:latin typeface="Arial" pitchFamily="34" charset="0"/>
-                <a:ea typeface="Arial" pitchFamily="34" charset="-122"/>
-                <a:cs typeface="Arial" pitchFamily="34" charset="-120"/>
-              </a:rPr>
-              <a:t>חרוב מצוי: האבקה בחרקים והפצה ביונקים</a:t>
+                  <a:srgbClr val="A8353A"/>
+                </a:solidFill>
+                <a:latin typeface="Arial" pitchFamily="34" charset="0"/>
+                <a:ea typeface="Arial" pitchFamily="34" charset="-122"/>
+                <a:cs typeface="Arial" pitchFamily="34" charset="-120"/>
+              </a:rPr>
+              <a:t>היביסקוס סיני: האבקה בבעלי חיים והפצה בעזרת האדם</a:t>
             </a:r>
             <a:endParaRPr lang="en-US" sz="2600" dirty="0"/>
           </a:p>
@@ -3392,7 +3392,7 @@
                 <a:ea typeface="Arial" pitchFamily="34" charset="-122"/>
                 <a:cs typeface="Arial" pitchFamily="34" charset="-120"/>
               </a:rPr>
-              <a:t>צורת האבקה (ה): בעיקר חרקים</a:t>
+              <a:t>צורת האבקה (ה): ציפורים וחרקים</a:t>
             </a:r>
             <a:endParaRPr lang="en-US" sz="1600" dirty="0"/>
           </a:p>
@@ -3438,7 +3438,7 @@
                 <a:ea typeface="Arial" pitchFamily="34" charset="-122"/>
                 <a:cs typeface="Arial" pitchFamily="34" charset="-120"/>
               </a:rPr>
-              <a:t>פורח בסתיו, בניגוד לרוב עצי החורש</a:t>
+              <a:t>פרח גדול, אדום ועשיר בצוף: מבנה המותאם להאבקה על ידי בעלי חיים</a:t>
             </a:r>
             <a:endParaRPr lang="en-US" sz="1450" dirty="0"/>
           </a:p>
@@ -3462,7 +3462,7 @@
                 <a:ea typeface="Arial" pitchFamily="34" charset="-122"/>
                 <a:cs typeface="Arial" pitchFamily="34" charset="-120"/>
               </a:rPr>
-              <a:t>התפרחות מדיפות ריח חזק המושך את המאביקים</a:t>
+              <a:t>באזורי מוצאו מואבק בעיקר על ידי ציפורים צופיות ופרפרים</a:t>
             </a:r>
             <a:endParaRPr lang="en-US" sz="1450" dirty="0"/>
           </a:p>
@@ -3486,7 +3486,7 @@
                 <a:ea typeface="Arial" pitchFamily="34" charset="-122"/>
                 <a:cs typeface="Arial" pitchFamily="34" charset="-120"/>
               </a:rPr>
-              <a:t>המאביקים העיקריים: זבובים ודבורים, וייתכן שגם הרוח תורמת</a:t>
+              <a:t>בישראל אפשר לראות בפרחים את הצופית הבוהקת וגם דבורים</a:t>
             </a:r>
             <a:endParaRPr lang="en-US" sz="1450" dirty="0"/>
           </a:p>
@@ -3510,7 +3510,7 @@
                 <a:ea typeface="Arial" pitchFamily="34" charset="-122"/>
                 <a:cs typeface="Arial" pitchFamily="34" charset="-120"/>
               </a:rPr>
-              <a:t>המאביקים מעבירים אבקה מעצי הזכר לפרחי עצי הנקבה</a:t>
+              <a:t>האבקנים והצלקות בולטים על עמוד מרכזי ונוגעים במבקרים בפרח</a:t>
             </a:r>
             <a:endParaRPr lang="en-US" sz="1450" dirty="0"/>
           </a:p>
@@ -3533,7 +3533,7 @@
             </a:avLst>
           </a:prstGeom>
           <a:solidFill>
-            <a:srgbClr val="F5EDE1"/>
+            <a:srgbClr val="F8EAE8"/>
           </a:solidFill>
           <a:ln/>
         </p:spPr>
@@ -3609,13 +3609,13 @@
             <a:r>
               <a:rPr lang="en-US" sz="1600" b="1" dirty="0">
                 <a:solidFill>
-                  <a:srgbClr val="8A5A2B"/>
-                </a:solidFill>
-                <a:latin typeface="Arial" pitchFamily="34" charset="0"/>
-                <a:ea typeface="Arial" pitchFamily="34" charset="-122"/>
-                <a:cs typeface="Arial" pitchFamily="34" charset="-120"/>
-              </a:rPr>
-              <a:t>הפצת זרעים (ו): יונקים אוכלי פרי</a:t>
+                  <a:srgbClr val="A8353A"/>
+                </a:solidFill>
+                <a:latin typeface="Arial" pitchFamily="34" charset="0"/>
+                <a:ea typeface="Arial" pitchFamily="34" charset="-122"/>
+                <a:cs typeface="Arial" pitchFamily="34" charset="-120"/>
+              </a:rPr>
+              <a:t>הפצת זרעים (ו): הלקט, ובפועל האדם</a:t>
             </a:r>
             <a:endParaRPr lang="en-US" sz="1600" dirty="0"/>
           </a:p>
@@ -3661,7 +3661,7 @@
                 <a:ea typeface="Arial" pitchFamily="34" charset="-122"/>
                 <a:cs typeface="Arial" pitchFamily="34" charset="-120"/>
               </a:rPr>
-              <a:t>התרמיל הבשל מתוק ועשיר בסוכרים: פיתיון לבעלי חיים</a:t>
+              <a:t>הפרי הוא הלקט יבש שנפתח בהבשלתו, והזרעים נושרים סמוך לצמח האם</a:t>
             </a:r>
             <a:endParaRPr lang="en-US" sz="1450" dirty="0"/>
           </a:p>
@@ -3685,7 +3685,7 @@
                 <a:ea typeface="Arial" pitchFamily="34" charset="-122"/>
                 <a:cs typeface="Arial" pitchFamily="34" charset="-120"/>
               </a:rPr>
-              <a:t>שועלים, תנים, מכרסמים ובהמות בית אוכלים את התרמילים</a:t>
+              <a:t>רוב זני התרבות כמעט אינם חונטים פרי, ולכן זרעים נדירים בגינה</a:t>
             </a:r>
             <a:endParaRPr lang="en-US" sz="1450" dirty="0"/>
           </a:p>
@@ -3709,7 +3709,7 @@
                 <a:ea typeface="Arial" pitchFamily="34" charset="-122"/>
                 <a:cs typeface="Arial" pitchFamily="34" charset="-120"/>
               </a:rPr>
-              <a:t>הזרעים הקשים שורדים את מערכת העיכול ומופרשים הרחק מעץ האם, מוכנים לנביטה</a:t>
+              <a:t>בפועל האדם הוא המפיץ העיקרי: ריבוי וגטטיבי מייחורים ושתילה בגינות</a:t>
             </a:r>
             <a:endParaRPr lang="en-US" sz="1450" dirty="0"/>
           </a:p>
@@ -3824,7 +3824,7 @@
                 <a:ea typeface="Arial" pitchFamily="34" charset="-122"/>
                 <a:cs typeface="Arial" pitchFamily="34" charset="-120"/>
               </a:rPr>
-              <a:t>שני העצים זה מול זה</a:t>
+              <a:t>שני הצמחים זה מול זה</a:t>
             </a:r>
             <a:endParaRPr lang="en-US" sz="2800" dirty="0"/>
           </a:p>
@@ -3863,7 +3863,7 @@
                 <a:ea typeface="Arial" pitchFamily="34" charset="-122"/>
                 <a:cs typeface="Arial" pitchFamily="34" charset="-120"/>
               </a:rPr>
-              <a:t>אותן משימות, פתרונות הפוכים</a:t>
+              <a:t>אותן משימות, פתרונות שונים</a:t>
             </a:r>
             <a:endParaRPr lang="en-US" sz="1400" dirty="0"/>
           </a:p>
@@ -3896,7 +3896,7 @@
                 <a:gridCol w="4206240"/>
                 <a:gridCol w="2404872"/>
               </a:tblGrid>
-              <a:tr h="640080">
+              <a:tr h="560070">
                 <a:tc>
                   <a:txBody>
                     <a:bodyPr/>
@@ -3914,7 +3914,7 @@
                           <a:ea typeface="Arial" pitchFamily="34" charset="-122"/>
                           <a:cs typeface="Arial" pitchFamily="34" charset="-120"/>
                         </a:rPr>
-                        <a:t>חרוב מצוי</a:t>
+                        <a:t>היביסקוס סיני</a:t>
                       </a:r>
                       <a:endParaRPr lang="en-US" sz="1400" dirty="0">
                         <a:latin typeface="Arial" charset="0"/>
@@ -3961,7 +3961,7 @@
                       <a:tailEnd type="none" w="med" len="med"/>
                     </a:lnB>
                     <a:solidFill>
-                      <a:srgbClr val="8A5A2B"/>
+                      <a:srgbClr val="A8353A"/>
                     </a:solidFill>
                   </a:tcPr>
                 </a:tc>
@@ -4087,7 +4087,7 @@
                   </a:tcPr>
                 </a:tc>
               </a:tr>
-              <a:tr h="640080">
+              <a:tr h="560070">
                 <a:tc>
                   <a:txBody>
                     <a:bodyPr/>
@@ -4105,7 +4105,7 @@
                           <a:ea typeface="Arial" pitchFamily="34" charset="-122"/>
                           <a:cs typeface="Arial" pitchFamily="34" charset="-120"/>
                         </a:rPr>
-                        <a:t>מכוסי זרע (קטניות)</a:t>
+                        <a:t>מכוסי זרע (חלמיתיים)</a:t>
                       </a:r>
                       <a:endParaRPr lang="en-US" sz="1250" dirty="0">
                         <a:latin typeface="Arial" charset="0"/>
@@ -4293,7 +4293,7 @@
                   </a:tcPr>
                 </a:tc>
               </a:tr>
-              <a:tr h="640080">
+              <a:tr h="560070">
                 <a:tc>
                   <a:txBody>
                     <a:bodyPr/>
@@ -4311,7 +4311,213 @@
                           <a:ea typeface="Arial" pitchFamily="34" charset="-122"/>
                           <a:cs typeface="Arial" pitchFamily="34" charset="-120"/>
                         </a:rPr>
-                        <a:t>פרחים בתפרחות, זרעים בתוך תרמיל</a:t>
+                        <a:t>שיח מסועף, 1 עד 3 מטרים</a:t>
+                      </a:r>
+                      <a:endParaRPr lang="en-US" sz="1250" dirty="0">
+                        <a:latin typeface="Arial" charset="0"/>
+                        <a:ea typeface="Arial" charset="0"/>
+                        <a:cs typeface="Arial" charset="0"/>
+                      </a:endParaRPr>
+                    </a:p>
+                  </a:txBody>
+                  <a:tcPr marL="109728" marR="109728" marT="54864" marB="54864" anchor="ctr">
+                    <a:lnL w="19050" cap="flat" cmpd="sng" algn="ctr">
+                      <a:solidFill>
+                        <a:srgbClr val="FFFFFF"/>
+                      </a:solidFill>
+                      <a:prstDash val="solid"/>
+                      <a:round/>
+                      <a:headEnd type="none" w="med" len="med"/>
+                      <a:tailEnd type="none" w="med" len="med"/>
+                    </a:lnL>
+                    <a:lnR w="19050" cap="flat" cmpd="sng" algn="ctr">
+                      <a:solidFill>
+                        <a:srgbClr val="FFFFFF"/>
+                      </a:solidFill>
+                      <a:prstDash val="solid"/>
+                      <a:round/>
+                      <a:headEnd type="none" w="med" len="med"/>
+                      <a:tailEnd type="none" w="med" len="med"/>
+                    </a:lnR>
+                    <a:lnT w="19050" cap="flat" cmpd="sng" algn="ctr">
+                      <a:solidFill>
+                        <a:srgbClr val="FFFFFF"/>
+                      </a:solidFill>
+                      <a:prstDash val="solid"/>
+                      <a:round/>
+                      <a:headEnd type="none" w="med" len="med"/>
+                      <a:tailEnd type="none" w="med" len="med"/>
+                    </a:lnT>
+                    <a:lnB w="19050" cap="flat" cmpd="sng" algn="ctr">
+                      <a:solidFill>
+                        <a:srgbClr val="FFFFFF"/>
+                      </a:solidFill>
+                      <a:prstDash val="solid"/>
+                      <a:round/>
+                      <a:headEnd type="none" w="med" len="med"/>
+                      <a:tailEnd type="none" w="med" len="med"/>
+                    </a:lnB>
+                    <a:solidFill>
+                      <a:srgbClr val="FBF8F2"/>
+                    </a:solidFill>
+                  </a:tcPr>
+                </a:tc>
+                <a:tc>
+                  <a:txBody>
+                    <a:bodyPr/>
+                    <a:lstStyle/>
+                    <a:p>
+                      <a:pPr rtl="1" algn="r" indent="0" marL="0">
+                        <a:buNone/>
+                      </a:pPr>
+                      <a:r>
+                        <a:rPr lang="en-US" sz="1250" dirty="0">
+                          <a:solidFill>
+                            <a:srgbClr val="26331F"/>
+                          </a:solidFill>
+                          <a:latin typeface="Arial" pitchFamily="34" charset="0"/>
+                          <a:ea typeface="Arial" pitchFamily="34" charset="-122"/>
+                          <a:cs typeface="Arial" pitchFamily="34" charset="-120"/>
+                        </a:rPr>
+                        <a:t>עץ בעל גזע מרכזי, 10 עד 20 מטרים</a:t>
+                      </a:r>
+                      <a:endParaRPr lang="en-US" sz="1250" dirty="0">
+                        <a:latin typeface="Arial" charset="0"/>
+                        <a:ea typeface="Arial" charset="0"/>
+                        <a:cs typeface="Arial" charset="0"/>
+                      </a:endParaRPr>
+                    </a:p>
+                  </a:txBody>
+                  <a:tcPr marL="109728" marR="109728" marT="54864" marB="54864" anchor="ctr">
+                    <a:lnL w="19050" cap="flat" cmpd="sng" algn="ctr">
+                      <a:solidFill>
+                        <a:srgbClr val="FFFFFF"/>
+                      </a:solidFill>
+                      <a:prstDash val="solid"/>
+                      <a:round/>
+                      <a:headEnd type="none" w="med" len="med"/>
+                      <a:tailEnd type="none" w="med" len="med"/>
+                    </a:lnL>
+                    <a:lnR w="19050" cap="flat" cmpd="sng" algn="ctr">
+                      <a:solidFill>
+                        <a:srgbClr val="FFFFFF"/>
+                      </a:solidFill>
+                      <a:prstDash val="solid"/>
+                      <a:round/>
+                      <a:headEnd type="none" w="med" len="med"/>
+                      <a:tailEnd type="none" w="med" len="med"/>
+                    </a:lnR>
+                    <a:lnT w="19050" cap="flat" cmpd="sng" algn="ctr">
+                      <a:solidFill>
+                        <a:srgbClr val="FFFFFF"/>
+                      </a:solidFill>
+                      <a:prstDash val="solid"/>
+                      <a:round/>
+                      <a:headEnd type="none" w="med" len="med"/>
+                      <a:tailEnd type="none" w="med" len="med"/>
+                    </a:lnT>
+                    <a:lnB w="19050" cap="flat" cmpd="sng" algn="ctr">
+                      <a:solidFill>
+                        <a:srgbClr val="FFFFFF"/>
+                      </a:solidFill>
+                      <a:prstDash val="solid"/>
+                      <a:round/>
+                      <a:headEnd type="none" w="med" len="med"/>
+                      <a:tailEnd type="none" w="med" len="med"/>
+                    </a:lnB>
+                    <a:solidFill>
+                      <a:srgbClr val="F4F8F6"/>
+                    </a:solidFill>
+                  </a:tcPr>
+                </a:tc>
+                <a:tc>
+                  <a:txBody>
+                    <a:bodyPr/>
+                    <a:lstStyle/>
+                    <a:p>
+                      <a:pPr rtl="1" algn="r" indent="0" marL="0">
+                        <a:buNone/>
+                      </a:pPr>
+                      <a:r>
+                        <a:rPr lang="en-US" sz="1250" b="1" dirty="0">
+                          <a:solidFill>
+                            <a:srgbClr val="2C5F2D"/>
+                          </a:solidFill>
+                          <a:latin typeface="Arial" pitchFamily="34" charset="0"/>
+                          <a:ea typeface="Arial" pitchFamily="34" charset="-122"/>
+                          <a:cs typeface="Arial" pitchFamily="34" charset="-120"/>
+                        </a:rPr>
+                        <a:t>צורת חיים</a:t>
+                      </a:r>
+                      <a:endParaRPr lang="en-US" sz="1250" dirty="0">
+                        <a:latin typeface="Arial" charset="0"/>
+                        <a:ea typeface="Arial" charset="0"/>
+                        <a:cs typeface="Arial" charset="0"/>
+                      </a:endParaRPr>
+                    </a:p>
+                  </a:txBody>
+                  <a:tcPr marL="109728" marR="109728" marT="54864" marB="54864" anchor="ctr">
+                    <a:lnL w="19050" cap="flat" cmpd="sng" algn="ctr">
+                      <a:solidFill>
+                        <a:srgbClr val="FFFFFF"/>
+                      </a:solidFill>
+                      <a:prstDash val="solid"/>
+                      <a:round/>
+                      <a:headEnd type="none" w="med" len="med"/>
+                      <a:tailEnd type="none" w="med" len="med"/>
+                    </a:lnL>
+                    <a:lnR w="19050" cap="flat" cmpd="sng" algn="ctr">
+                      <a:solidFill>
+                        <a:srgbClr val="FFFFFF"/>
+                      </a:solidFill>
+                      <a:prstDash val="solid"/>
+                      <a:round/>
+                      <a:headEnd type="none" w="med" len="med"/>
+                      <a:tailEnd type="none" w="med" len="med"/>
+                    </a:lnR>
+                    <a:lnT w="19050" cap="flat" cmpd="sng" algn="ctr">
+                      <a:solidFill>
+                        <a:srgbClr val="FFFFFF"/>
+                      </a:solidFill>
+                      <a:prstDash val="solid"/>
+                      <a:round/>
+                      <a:headEnd type="none" w="med" len="med"/>
+                      <a:tailEnd type="none" w="med" len="med"/>
+                    </a:lnT>
+                    <a:lnB w="19050" cap="flat" cmpd="sng" algn="ctr">
+                      <a:solidFill>
+                        <a:srgbClr val="FFFFFF"/>
+                      </a:solidFill>
+                      <a:prstDash val="solid"/>
+                      <a:round/>
+                      <a:headEnd type="none" w="med" len="med"/>
+                      <a:tailEnd type="none" w="med" len="med"/>
+                    </a:lnB>
+                    <a:solidFill>
+                      <a:srgbClr val="F0F4EA"/>
+                    </a:solidFill>
+                  </a:tcPr>
+                </a:tc>
+              </a:tr>
+              <a:tr h="560070">
+                <a:tc>
+                  <a:txBody>
+                    <a:bodyPr/>
+                    <a:lstStyle/>
+                    <a:p>
+                      <a:pPr rtl="1" algn="r" indent="0" marL="0">
+                        <a:buNone/>
+                      </a:pPr>
+                      <a:r>
+                        <a:rPr lang="en-US" sz="1250" dirty="0">
+                          <a:solidFill>
+                            <a:srgbClr val="26331F"/>
+                          </a:solidFill>
+                          <a:latin typeface="Arial" pitchFamily="34" charset="0"/>
+                          <a:ea typeface="Arial" pitchFamily="34" charset="-122"/>
+                          <a:cs typeface="Arial" pitchFamily="34" charset="-120"/>
+                        </a:rPr>
+                        <a:t>פרחים גדולים, זרעים בתוך הלקט</a:t>
                       </a:r>
                       <a:endParaRPr lang="en-US" sz="1250" dirty="0">
                         <a:latin typeface="Arial" charset="0"/>
@@ -4499,7 +4705,7 @@
                   </a:tcPr>
                 </a:tc>
               </a:tr>
-              <a:tr h="640080">
+              <a:tr h="560070">
                 <a:tc>
                   <a:txBody>
                     <a:bodyPr/>
@@ -4517,7 +4723,7 @@
                           <a:ea typeface="Arial" pitchFamily="34" charset="-122"/>
                           <a:cs typeface="Arial" pitchFamily="34" charset="-120"/>
                         </a:rPr>
-                        <a:t>עלים מנוצים רחבים ומבריקים</a:t>
+                        <a:t>עלים רחבים, מבריקים ומשוננים</a:t>
                       </a:r>
                       <a:endParaRPr lang="en-US" sz="1250" dirty="0">
                         <a:latin typeface="Arial" charset="0"/>
@@ -4705,7 +4911,7 @@
                   </a:tcPr>
                 </a:tc>
               </a:tr>
-              <a:tr h="640080">
+              <a:tr h="560070">
                 <a:tc>
                   <a:txBody>
                     <a:bodyPr/>
@@ -4723,7 +4929,7 @@
                           <a:ea typeface="Arial" pitchFamily="34" charset="-122"/>
                           <a:cs typeface="Arial" pitchFamily="34" charset="-120"/>
                         </a:rPr>
-                        <a:t>בעיקר חרקים (זבובים ודבורים), בסתיו</a:t>
+                        <a:t>ציפורים צופיות, פרפרים ודבורים</a:t>
                       </a:r>
                       <a:endParaRPr lang="en-US" sz="1250" dirty="0">
                         <a:latin typeface="Arial" charset="0"/>
@@ -4911,7 +5117,7 @@
                   </a:tcPr>
                 </a:tc>
               </a:tr>
-              <a:tr h="640080">
+              <a:tr h="560070">
                 <a:tc>
                   <a:txBody>
                     <a:bodyPr/>
@@ -4929,7 +5135,7 @@
                           <a:ea typeface="Arial" pitchFamily="34" charset="-122"/>
                           <a:cs typeface="Arial" pitchFamily="34" charset="-120"/>
                         </a:rPr>
-                        <a:t>יונקים אוכלי פרי</a:t>
+                        <a:t>הלקט נפתח; בתרבות בעיקר האדם, בייחורים</a:t>
                       </a:r>
                       <a:endParaRPr lang="en-US" sz="1250" dirty="0">
                         <a:latin typeface="Arial" charset="0"/>
@@ -5117,7 +5323,7 @@
                   </a:tcPr>
                 </a:tc>
               </a:tr>
-              <a:tr h="640080">
+              <a:tr h="560070">
                 <a:tc>
                   <a:txBody>
                     <a:bodyPr/>
@@ -5135,7 +5341,7 @@
                           <a:ea typeface="Arial" pitchFamily="34" charset="-122"/>
                           <a:cs typeface="Arial" pitchFamily="34" charset="-120"/>
                         </a:rPr>
-                        <a:t>לרוב דו-ביתי: עצי זכר ועצי נקבה</a:t>
+                        <a:t>פרח דו-זוויגי: אבקנים ועלי באותו פרח</a:t>
                       </a:r>
                       <a:endParaRPr lang="en-US" sz="1250" dirty="0">
                         <a:latin typeface="Arial" charset="0"/>
@@ -5606,7 +5812,7 @@
                 <a:ea typeface="Arial" pitchFamily="34" charset="-122"/>
                 <a:cs typeface="Arial" pitchFamily="34" charset="-120"/>
               </a:rPr>
-              <a:t>חרוב מצוי: פריחה בסתיו (ספטמבר עד נובמבר), התרמילים מבשילים בקיץ שאחרי, כשנה לאחר ההאבקה</a:t>
+              <a:t>היביסקוס סיני: פורח לאורך רוב השנה בישראל, ובעיקר בחודשים החמים; כל פרח נפתח ליום או יומיים בלבד</a:t>
             </a:r>
             <a:endParaRPr lang="en-US" sz="1450" dirty="0"/>
           </a:p>
@@ -5653,7 +5859,7 @@
             </a:avLst>
           </a:prstGeom>
           <a:solidFill>
-            <a:srgbClr val="F5EDE1"/>
+            <a:srgbClr val="F8EAE8"/>
           </a:solidFill>
           <a:ln/>
         </p:spPr>
@@ -5685,7 +5891,7 @@
             <a:r>
               <a:rPr lang="en-US" sz="1600" b="1" dirty="0">
                 <a:solidFill>
-                  <a:srgbClr val="8A5A2B"/>
+                  <a:srgbClr val="A8353A"/>
                 </a:solidFill>
                 <a:latin typeface="Arial" pitchFamily="34" charset="0"/>
                 <a:ea typeface="Arial" pitchFamily="34" charset="-122"/>
@@ -5737,7 +5943,7 @@
                 <a:ea typeface="Arial" pitchFamily="34" charset="-122"/>
                 <a:cs typeface="Arial" pitchFamily="34" charset="-120"/>
               </a:rPr>
-              <a:t>חרוב: מקור מזון עתיק; מזרעיו האחידים יחסית נגזרה יחידת המשקל קראט של אבני החן</a:t>
+              <a:t>היביסקוס סיני: מצמחי הנוי הוותיקים והנפוצים בעולם, והפרח הלאומי של מלזיה</a:t>
             </a:r>
             <a:endParaRPr lang="en-US" sz="1450" dirty="0"/>
           </a:p>
@@ -5761,7 +5967,7 @@
                 <a:ea typeface="Arial" pitchFamily="34" charset="-122"/>
                 <a:cs typeface="Arial" pitchFamily="34" charset="-120"/>
               </a:rPr>
-              <a:t>חרוב במסורת: 'חרובים אכל חוני המעגל', סמל לסבלנות, כי העץ נותן פרי שנים רבות אחרי הנטיעה</a:t>
+              <a:t>שמו המדעי, rosa-sinensis, פירושו 'ורד סיני', עדות לדרך שעשה מאסיה לגינות העולם</a:t>
             </a:r>
             <a:endParaRPr lang="en-US" sz="1450" dirty="0"/>
           </a:p>
@@ -6026,7 +6232,7 @@
             </a:avLst>
           </a:prstGeom>
           <a:solidFill>
-            <a:srgbClr val="4A3A26"/>
+            <a:srgbClr val="4A2529"/>
           </a:solidFill>
           <a:ln/>
         </p:spPr>
@@ -6046,7 +6252,7 @@
             <a:avLst/>
           </a:prstGeom>
           <a:solidFill>
-            <a:srgbClr val="8A5A2B"/>
+            <a:srgbClr val="A8353A"/>
           </a:solidFill>
           <a:ln/>
         </p:spPr>
@@ -6108,7 +6314,7 @@
                 <a:ea typeface="Arial" pitchFamily="34" charset="-122"/>
                 <a:cs typeface="Arial" pitchFamily="34" charset="-120"/>
               </a:rPr>
-              <a:t>חרוב מצוי</a:t>
+              <a:t>היביסקוס סיני</a:t>
             </a:r>
             <a:endParaRPr lang="en-US" sz="1800" dirty="0"/>
           </a:p>
@@ -6144,13 +6350,13 @@
             <a:r>
               <a:rPr lang="en-US" sz="1350" dirty="0">
                 <a:solidFill>
-                  <a:srgbClr val="EBDDC4"/>
-                </a:solidFill>
-                <a:latin typeface="Arial" pitchFamily="34" charset="0"/>
-                <a:ea typeface="Arial" pitchFamily="34" charset="-122"/>
-                <a:cs typeface="Arial" pitchFamily="34" charset="-120"/>
-              </a:rPr>
-              <a:t>מכוסה זרע שמגייס בעלי חיים: חרקים מאביקים את פרחי הסתיו, ויונקים מפיצים את הזרעים בתרמיל המתוק</a:t>
+                  <a:srgbClr val="F0D9D6"/>
+                </a:solidFill>
+                <a:latin typeface="Arial" pitchFamily="34" charset="0"/>
+                <a:ea typeface="Arial" pitchFamily="34" charset="-122"/>
+                <a:cs typeface="Arial" pitchFamily="34" charset="-120"/>
+              </a:rPr>
+              <a:t>מכוסה זרע עם פרח ראווה שמושך ציפורים ופרפרים, וצמח תרבות שאת הפצתו בעולם עשה האדם</a:t>
             </a:r>
             <a:endParaRPr lang="en-US" sz="1350" dirty="0"/>
           </a:p>
@@ -6189,7 +6395,7 @@
                 <a:ea typeface="Arial" pitchFamily="34" charset="-122"/>
                 <a:cs typeface="Arial" pitchFamily="34" charset="-120"/>
               </a:rPr>
-              <a:t>שני שכנים באותו חורש, ושתי אסטרטגיות רבייה שהתפתחו במרחק של עשרות מיליוני שנים זו מזו</a:t>
+              <a:t>עץ בר ושיח גינה, ושתי אסטרטגיות רבייה שונות לגמרי של צמחים בעלי זרעים</a:t>
             </a:r>
             <a:endParaRPr lang="en-US" sz="1600" dirty="0"/>
           </a:p>
@@ -6398,7 +6604,7 @@
                 <a:ea typeface="Arial" pitchFamily="34" charset="-122"/>
                 <a:cs typeface="Arial" pitchFamily="34" charset="-120"/>
               </a:rPr>
-              <a:t>להשלים לפני ההגשה: דפי המין של אורן ירושלים ושל חרוב מצוי באתר שבו נעזרתם, למשל צמח השדה או צמחיית ישראל ברשת, עם קישור מלא ותאריך אחזור.‏</a:t>
+              <a:t>להשלים לפני ההגשה: דפי מידע על אורן ירושלים (למשל צמח השדה או צמחיית ישראל ברשת) ועל היביסקוס סיני באתרים שבהם נעזרתם, עם קישור מלא ותאריך אחזור.‏</a:t>
             </a:r>
             <a:endParaRPr lang="en-US" sz="1400" dirty="0"/>
           </a:p>
@@ -8330,7 +8536,7 @@
             </a:avLst>
           </a:prstGeom>
           <a:solidFill>
-            <a:srgbClr val="F5EDE1"/>
+            <a:srgbClr val="F8EAE8"/>
           </a:solidFill>
           <a:ln/>
         </p:spPr>
@@ -8406,7 +8612,7 @@
             <a:r>
               <a:rPr lang="en-US" sz="1900" b="1" dirty="0">
                 <a:solidFill>
-                  <a:srgbClr val="8A5A2B"/>
+                  <a:srgbClr val="A8353A"/>
                 </a:solidFill>
                 <a:latin typeface="Arial" pitchFamily="34" charset="0"/>
                 <a:ea typeface="Arial" pitchFamily="34" charset="-122"/>
@@ -8599,7 +8805,7 @@
                 <a:ea typeface="Arial" pitchFamily="34" charset="-122"/>
                 <a:cs typeface="Arial" pitchFamily="34" charset="-120"/>
               </a:rPr>
-              <a:t>העץ הראשון · חשוף זרע</a:t>
+              <a:t>הצמח הראשון · חשוף זרע</a:t>
             </a:r>
             <a:endParaRPr lang="en-US" sz="1250" dirty="0"/>
           </a:p>
@@ -9413,7 +9619,7 @@
                 <a:ea typeface="Arial" pitchFamily="34" charset="-122"/>
                 <a:cs typeface="Arial" pitchFamily="34" charset="-120"/>
               </a:rPr>
-              <a:t>העץ הראשון · חשוף זרע</a:t>
+              <a:t>הצמח הראשון · חשוף זרע</a:t>
             </a:r>
             <a:endParaRPr lang="en-US" sz="1250" dirty="0"/>
           </a:p>
@@ -9964,7 +10170,7 @@
                 <a:ea typeface="Arial" pitchFamily="34" charset="-122"/>
                 <a:cs typeface="Arial" pitchFamily="34" charset="-120"/>
               </a:rPr>
-              <a:t>העץ הראשון · חשוף זרע</a:t>
+              <a:t>הצמח הראשון · חשוף זרע</a:t>
             </a:r>
             <a:endParaRPr lang="en-US" sz="1250" dirty="0"/>
           </a:p>
@@ -10614,7 +10820,7 @@
                 <a:ea typeface="Arial" pitchFamily="34" charset="-122"/>
                 <a:cs typeface="Arial" pitchFamily="34" charset="-120"/>
               </a:rPr>
-              <a:t>העץ הראשון · חשוף זרע</a:t>
+              <a:t>הצמח הראשון · חשוף זרע</a:t>
             </a:r>
             <a:endParaRPr lang="en-US" sz="1250" dirty="0"/>
           </a:p>
@@ -11167,7 +11373,7 @@
             </a:avLst>
           </a:prstGeom>
           <a:solidFill>
-            <a:srgbClr val="8A5A2B"/>
+            <a:srgbClr val="A8353A"/>
           </a:solidFill>
           <a:ln/>
         </p:spPr>
@@ -11205,7 +11411,7 @@
                 <a:ea typeface="Arial" pitchFamily="34" charset="-122"/>
                 <a:cs typeface="Arial" pitchFamily="34" charset="-120"/>
               </a:rPr>
-              <a:t>העץ השני · מכוסה זרע</a:t>
+              <a:t>הצמח השני · מכוסה זרע</a:t>
             </a:r>
             <a:endParaRPr lang="en-US" sz="1250" dirty="0"/>
           </a:p>
@@ -11238,13 +11444,13 @@
             <a:r>
               <a:rPr lang="en-US" sz="3000" b="1" dirty="0">
                 <a:solidFill>
-                  <a:srgbClr val="8A5A2B"/>
-                </a:solidFill>
-                <a:latin typeface="Arial" pitchFamily="34" charset="0"/>
-                <a:ea typeface="Arial" pitchFamily="34" charset="-122"/>
-                <a:cs typeface="Arial" pitchFamily="34" charset="-120"/>
-              </a:rPr>
-              <a:t>חרוב מצוי </a:t>
+                  <a:srgbClr val="A8353A"/>
+                </a:solidFill>
+                <a:latin typeface="Arial" pitchFamily="34" charset="0"/>
+                <a:ea typeface="Arial" pitchFamily="34" charset="-122"/>
+                <a:cs typeface="Arial" pitchFamily="34" charset="-120"/>
+              </a:rPr>
+              <a:t>היביסקוס סיני </a:t>
             </a:r>
             <a:pPr algn="r" indent="0" marL="0">
               <a:buNone/>
@@ -11258,7 +11464,7 @@
                 <a:ea typeface="Times New Roman" pitchFamily="34" charset="-122"/>
                 <a:cs typeface="Times New Roman" pitchFamily="34" charset="-120"/>
               </a:rPr>
-              <a:t>(Ceratonia siliqua)</a:t>
+              <a:t>(Hibiscus rosa-sinensis)</a:t>
             </a:r>
             <a:endParaRPr lang="en-US" sz="3000" dirty="0"/>
           </a:p>
@@ -11374,7 +11580,7 @@
             <a:r>
               <a:rPr lang="en-US" sz="1400" b="1" dirty="0">
                 <a:solidFill>
-                  <a:srgbClr val="8A5A2B"/>
+                  <a:srgbClr val="A8353A"/>
                 </a:solidFill>
                 <a:latin typeface="Arial" pitchFamily="34" charset="0"/>
                 <a:ea typeface="Arial" pitchFamily="34" charset="-122"/>
@@ -11474,7 +11680,7 @@
             <a:r>
               <a:rPr lang="en-US" sz="1400" b="1" dirty="0">
                 <a:solidFill>
-                  <a:srgbClr val="8A5A2B"/>
+                  <a:srgbClr val="A8353A"/>
                 </a:solidFill>
                 <a:latin typeface="Arial" pitchFamily="34" charset="0"/>
                 <a:ea typeface="Arial" pitchFamily="34" charset="-122"/>
@@ -11574,7 +11780,7 @@
             <a:r>
               <a:rPr lang="en-US" sz="1400" b="1" dirty="0">
                 <a:solidFill>
-                  <a:srgbClr val="8A5A2B"/>
+                  <a:srgbClr val="A8353A"/>
                 </a:solidFill>
                 <a:latin typeface="Arial" pitchFamily="34" charset="0"/>
                 <a:ea typeface="Arial" pitchFamily="34" charset="-122"/>
@@ -11619,7 +11825,7 @@
                 <a:ea typeface="Arial" pitchFamily="34" charset="-122"/>
                 <a:cs typeface="Arial" pitchFamily="34" charset="-120"/>
               </a:rPr>
-              <a:t>קטניות (Fabaceae)</a:t>
+              <a:t>חלמיתיים (Malvaceae)</a:t>
             </a:r>
             <a:endParaRPr lang="en-US" sz="1350" dirty="0"/>
           </a:p>
@@ -11674,7 +11880,7 @@
             <a:r>
               <a:rPr lang="en-US" sz="1400" b="1" dirty="0">
                 <a:solidFill>
-                  <a:srgbClr val="8A5A2B"/>
+                  <a:srgbClr val="A8353A"/>
                 </a:solidFill>
                 <a:latin typeface="Arial" pitchFamily="34" charset="0"/>
                 <a:ea typeface="Arial" pitchFamily="34" charset="-122"/>
@@ -11719,7 +11925,7 @@
                 <a:ea typeface="Arial" pitchFamily="34" charset="-122"/>
                 <a:cs typeface="Arial" pitchFamily="34" charset="-120"/>
               </a:rPr>
-              <a:t>חרוב (Ceratonia)</a:t>
+              <a:t>היביסקוס (Hibiscus)</a:t>
             </a:r>
             <a:endParaRPr lang="en-US" sz="1350" dirty="0"/>
           </a:p>
@@ -11742,7 +11948,7 @@
             </a:avLst>
           </a:prstGeom>
           <a:solidFill>
-            <a:srgbClr val="F5EDE1"/>
+            <a:srgbClr val="F8EAE8"/>
           </a:solidFill>
           <a:ln/>
         </p:spPr>
@@ -11774,7 +11980,7 @@
             <a:r>
               <a:rPr lang="en-US" sz="1400" b="1" dirty="0">
                 <a:solidFill>
-                  <a:srgbClr val="8A5A2B"/>
+                  <a:srgbClr val="A8353A"/>
                 </a:solidFill>
                 <a:latin typeface="Arial" pitchFamily="34" charset="0"/>
                 <a:ea typeface="Arial" pitchFamily="34" charset="-122"/>
@@ -11819,42 +12025,15 @@
                 <a:ea typeface="Arial" pitchFamily="34" charset="-122"/>
                 <a:cs typeface="Arial" pitchFamily="34" charset="-120"/>
               </a:rPr>
-              <a:t>חרוב מצוי (Ceratonia siliqua)</a:t>
+              <a:t>היביסקוס סיני (Hibiscus rosa-sinensis)</a:t>
             </a:r>
             <a:endParaRPr lang="en-US" sz="1350" dirty="0"/>
           </a:p>
         </p:txBody>
-      </p:sp>
-      <p:sp>
-        <p:nvSpPr>
-          <p:cNvPr id="22" name="Shape 20"/>
-          <p:cNvSpPr/>
-          <p:nvPr/>
-        </p:nvSpPr>
-        <p:spPr>
-          <a:xfrm>
-            <a:off x="594360" y="1783080"/>
-            <a:ext cx="4892040" cy="4434840"/>
-          </a:xfrm>
-          <a:prstGeom prst="roundRect">
-            <a:avLst>
-              <a:gd name="adj" fmla="val 2474"/>
-            </a:avLst>
-          </a:prstGeom>
-          <a:solidFill>
-            <a:srgbClr val="FAFBF7"/>
-          </a:solidFill>
-          <a:ln w="19050">
-            <a:solidFill>
-              <a:srgbClr val="97BC62"/>
-            </a:solidFill>
-            <a:prstDash val="dash"/>
-          </a:ln>
-        </p:spPr>
       </p:sp>
       <p:pic>
         <p:nvPicPr>
-          <p:cNvPr id="23" name="Image 0" descr="preencoded.png">    </p:cNvPr>
+          <p:cNvPr id="22" name="Image 0" descr="hibiscus.jpg">    </p:cNvPr>
           <p:cNvPicPr>
             <a:picLocks noChangeAspect="1"/>
           </p:cNvPicPr>
@@ -11862,14 +12041,13 @@
         </p:nvPicPr>
         <p:blipFill>
           <a:blip r:embed="rId1"/>
-          <a:stretch>
-            <a:fillRect/>
-          </a:stretch>
+          <a:srcRect l="0" r="0" t="0" b="0"/>
+          <a:stretch/>
         </p:blipFill>
         <p:spPr>
           <a:xfrm>
-            <a:off x="2720340" y="3451860"/>
-            <a:ext cx="640080" cy="640080"/>
+            <a:off x="594360" y="1783080"/>
+            <a:ext cx="4892040" cy="4114800"/>
           </a:xfrm>
           <a:prstGeom prst="rect">
             <a:avLst/>
@@ -11878,14 +12056,14 @@
       </p:pic>
       <p:sp>
         <p:nvSpPr>
-          <p:cNvPr id="24" name="Text 21"/>
-          <p:cNvSpPr/>
-          <p:nvPr/>
-        </p:nvSpPr>
-        <p:spPr>
-          <a:xfrm>
-            <a:off x="777240" y="4137660"/>
-            <a:ext cx="4526280" cy="731520"/>
+          <p:cNvPr id="23" name="Text 20"/>
+          <p:cNvSpPr/>
+          <p:nvPr/>
+        </p:nvSpPr>
+        <p:spPr>
+          <a:xfrm>
+            <a:off x="594360" y="5943600"/>
+            <a:ext cx="4892040" cy="320040"/>
           </a:xfrm>
           <a:prstGeom prst="rect">
             <a:avLst/>
@@ -11909,24 +12087,7 @@
                 <a:ea typeface="Arial" pitchFamily="34" charset="-122"/>
                 <a:cs typeface="Arial" pitchFamily="34" charset="-120"/>
               </a:rPr>
-              <a:t>כאן תמונה או צילום וידאו שלכם ליד העץ:</a:t>
-            </a:r>
-            <a:endParaRPr lang="en-US" sz="1150" dirty="0"/>
-          </a:p>
-          <a:p>
-            <a:pPr rtl="1" algn="ctr" indent="0" marL="0">
-              <a:buNone/>
-            </a:pPr>
-            <a:r>
-              <a:rPr lang="en-US" sz="1150" dirty="0">
-                <a:solidFill>
-                  <a:srgbClr val="5F6E53"/>
-                </a:solidFill>
-                <a:latin typeface="Arial" pitchFamily="34" charset="0"/>
-                <a:ea typeface="Arial" pitchFamily="34" charset="-122"/>
-                <a:cs typeface="Arial" pitchFamily="34" charset="-120"/>
-              </a:rPr>
-              <a:t>מראה כללי של חרוב מצוי באזור המגורים</a:t>
+              <a:t>השיח שצולם באזור המגורים (צילום: המגיש/ה)</a:t>
             </a:r>
             <a:endParaRPr lang="en-US" sz="1150" dirty="0"/>
           </a:p>
@@ -11981,7 +12142,7 @@
             </a:avLst>
           </a:prstGeom>
           <a:solidFill>
-            <a:srgbClr val="8A5A2B"/>
+            <a:srgbClr val="A8353A"/>
           </a:solidFill>
           <a:ln/>
         </p:spPr>
@@ -12019,7 +12180,7 @@
                 <a:ea typeface="Arial" pitchFamily="34" charset="-122"/>
                 <a:cs typeface="Arial" pitchFamily="34" charset="-120"/>
               </a:rPr>
-              <a:t>העץ השני · מכוסה זרע</a:t>
+              <a:t>הצמח השני · מכוסה זרע</a:t>
             </a:r>
             <a:endParaRPr lang="en-US" sz="1250" dirty="0"/>
           </a:p>
@@ -12052,13 +12213,13 @@
             <a:r>
               <a:rPr lang="en-US" sz="2600" b="1" dirty="0">
                 <a:solidFill>
-                  <a:srgbClr val="8A5A2B"/>
-                </a:solidFill>
-                <a:latin typeface="Arial" pitchFamily="34" charset="0"/>
-                <a:ea typeface="Arial" pitchFamily="34" charset="-122"/>
-                <a:cs typeface="Arial" pitchFamily="34" charset="-120"/>
-              </a:rPr>
-              <a:t>חרוב מצוי: למה מכוסה זרע, ואיזו צורת חיים</a:t>
+                  <a:srgbClr val="A8353A"/>
+                </a:solidFill>
+                <a:latin typeface="Arial" pitchFamily="34" charset="0"/>
+                <a:ea typeface="Arial" pitchFamily="34" charset="-122"/>
+                <a:cs typeface="Arial" pitchFamily="34" charset="-120"/>
+              </a:rPr>
+              <a:t>היביסקוס סיני: למה מכוסה זרע, ואיזו צורת חיים</a:t>
             </a:r>
             <a:endParaRPr lang="en-US" sz="2600" dirty="0"/>
           </a:p>
@@ -12142,7 +12303,7 @@
             </a:avLst>
           </a:prstGeom>
           <a:solidFill>
-            <a:srgbClr val="F5EDE1"/>
+            <a:srgbClr val="F8EAE8"/>
           </a:solidFill>
           <a:ln/>
         </p:spPr>
@@ -12174,7 +12335,7 @@
             <a:r>
               <a:rPr lang="en-US" sz="1600" b="1" dirty="0">
                 <a:solidFill>
-                  <a:srgbClr val="8A5A2B"/>
+                  <a:srgbClr val="A8353A"/>
                 </a:solidFill>
                 <a:latin typeface="Arial" pitchFamily="34" charset="0"/>
                 <a:ea typeface="Arial" pitchFamily="34" charset="-122"/>
@@ -12226,7 +12387,7 @@
                 <a:ea typeface="Arial" pitchFamily="34" charset="-122"/>
                 <a:cs typeface="Arial" pitchFamily="34" charset="-120"/>
               </a:rPr>
-              <a:t>מפתח פרחים: קטנים, ירקרקים-אדמדמים, בתפרחות צפופות היוצאות מענפים מעוצים</a:t>
+              <a:t>פרח גדול ובולט: חמישה עלי כותרת אדומים סביב עמוד מרכזי שעליו האבקנים והצלקות, מבנה אופייני לחלמיתיים</a:t>
             </a:r>
             <a:endParaRPr lang="en-US" sz="1450" dirty="0"/>
           </a:p>
@@ -12250,7 +12411,7 @@
                 <a:ea typeface="Arial" pitchFamily="34" charset="-122"/>
                 <a:cs typeface="Arial" pitchFamily="34" charset="-120"/>
               </a:rPr>
-              <a:t>הזרעים מתפתחים בתוך פרי: תרמיל חום וארוך, האופייני למשפחת הקטניות</a:t>
+              <a:t>הביצית סגורה בתוך שחלה בבסיס הפרח, ולאחר הפריה הזרעים מתפתחים בתוך פרי הלקט</a:t>
             </a:r>
             <a:endParaRPr lang="en-US" sz="1450" dirty="0"/>
           </a:p>
@@ -12274,7 +12435,7 @@
                 <a:ea typeface="Arial" pitchFamily="34" charset="-122"/>
                 <a:cs typeface="Arial" pitchFamily="34" charset="-120"/>
               </a:rPr>
-              <a:t>הפרי עוטף את הזרעים, מגן עליהם ומסייע בהפצתם</a:t>
+              <a:t>פרח הראווה עצמו הוא כרטיס הביקור של מכוסי הזרע: איבר שנועד למשוך מאביקים</a:t>
             </a:r>
             <a:endParaRPr lang="en-US" sz="1450" dirty="0"/>
           </a:p>
@@ -12381,7 +12542,7 @@
                 <a:ea typeface="Arial" pitchFamily="34" charset="-122"/>
                 <a:cs typeface="Arial" pitchFamily="34" charset="-120"/>
               </a:rPr>
-              <a:t>עץ ירוק-עד רחב צמרת, בגובה 5 עד 10 מטרים</a:t>
+              <a:t>שיח רב-שנתי ירוק-עד, בדרך כלל בגובה מטר עד שלושה מטרים</a:t>
             </a:r>
             <a:endParaRPr lang="en-US" sz="1450" dirty="0"/>
           </a:p>
@@ -12405,7 +12566,7 @@
                 <a:ea typeface="Arial" pitchFamily="34" charset="-122"/>
                 <a:cs typeface="Arial" pitchFamily="34" charset="-120"/>
               </a:rPr>
-              <a:t>עלים מנוצים ובהם עלעלים עגולים, קשים ומבריקים: קוטיקולה עבה כהתאמה ליובש</a:t>
+              <a:t>מסועף מבסיסו, בלי גזע מרכזי, ולכן שיח ולא עץ</a:t>
             </a:r>
             <a:endParaRPr lang="en-US" sz="1450" dirty="0"/>
           </a:p>
@@ -12429,7 +12590,31 @@
                 <a:ea typeface="Arial" pitchFamily="34" charset="-122"/>
                 <a:cs typeface="Arial" pitchFamily="34" charset="-120"/>
               </a:rPr>
-              <a:t>לרוב עץ דו-ביתי: עצי זכר ועצי נקבה נפרדים, ורק עצי הנקבה נושאים תרמילים</a:t>
+              <a:t>עלים רחבים, מבריקים ומשוננים, מכוסים קוטיקולה</a:t>
+            </a:r>
+            <a:endParaRPr lang="en-US" sz="1450" dirty="0"/>
+          </a:p>
+          <a:p>
+            <a:pPr algn="r" marL="152400" indent="-152400">
+              <a:lnSpc>
+                <a:spcPct val="108000"/>
+              </a:lnSpc>
+              <a:spcAft>
+                <a:spcPts val="800"/>
+              </a:spcAft>
+              <a:buSzPct val="100000"/>
+              <a:buChar char="•"/>
+            </a:pPr>
+            <a:r>
+              <a:rPr lang="en-US" sz="1450" dirty="0">
+                <a:solidFill>
+                  <a:srgbClr val="26331F"/>
+                </a:solidFill>
+                <a:latin typeface="Arial" pitchFamily="34" charset="0"/>
+                <a:ea typeface="Arial" pitchFamily="34" charset="-122"/>
+                <a:cs typeface="Arial" pitchFamily="34" charset="-120"/>
+              </a:rPr>
+              <a:t>בגינון משמש גם כגדר חיה מעוצבת</a:t>
             </a:r>
             <a:endParaRPr lang="en-US" sz="1450" dirty="0"/>
           </a:p>

</xml_diff>

<commit_message>
Remove photo placeholder boxes from presentation slides
Co-Authored-By: Claude Fable 5 <noreply@anthropic.com>
Claude-Session: https://claude.ai/code/session_01MZ4UbxGnn8qpC5Lqb74Zf6
</commit_message>
<xml_diff>
--- a/presentation/botany-video-presentation.pptx
+++ b/presentation/botany-video-presentation.pptx
@@ -2651,8 +2651,8 @@
         </p:nvSpPr>
         <p:spPr>
           <a:xfrm>
-            <a:off x="5559552" y="1737360"/>
-            <a:ext cx="6035040" cy="2103120"/>
+            <a:off x="594360" y="1737360"/>
+            <a:ext cx="11000232" cy="2103120"/>
           </a:xfrm>
           <a:prstGeom prst="roundRect">
             <a:avLst>
@@ -2717,8 +2717,8 @@
         </p:nvSpPr>
         <p:spPr>
           <a:xfrm>
-            <a:off x="5879592" y="1965960"/>
-            <a:ext cx="4663440" cy="411480"/>
+            <a:off x="914400" y="1965960"/>
+            <a:ext cx="9628632" cy="411480"/>
           </a:xfrm>
           <a:prstGeom prst="rect">
             <a:avLst/>
@@ -2756,8 +2756,8 @@
         </p:nvSpPr>
         <p:spPr>
           <a:xfrm>
-            <a:off x="5879592" y="2423160"/>
-            <a:ext cx="5394960" cy="1280160"/>
+            <a:off x="914400" y="2423160"/>
+            <a:ext cx="9171432" cy="1280160"/>
           </a:xfrm>
           <a:prstGeom prst="rect">
             <a:avLst/>
@@ -2826,8 +2826,8 @@
         </p:nvSpPr>
         <p:spPr>
           <a:xfrm>
-            <a:off x="5559552" y="4069080"/>
-            <a:ext cx="6035040" cy="2103120"/>
+            <a:off x="594360" y="4069080"/>
+            <a:ext cx="11000232" cy="2103120"/>
           </a:xfrm>
           <a:prstGeom prst="roundRect">
             <a:avLst>
@@ -2892,8 +2892,8 @@
         </p:nvSpPr>
         <p:spPr>
           <a:xfrm>
-            <a:off x="5879592" y="4297680"/>
-            <a:ext cx="4663440" cy="411480"/>
+            <a:off x="914400" y="4297680"/>
+            <a:ext cx="9628632" cy="411480"/>
           </a:xfrm>
           <a:prstGeom prst="rect">
             <a:avLst/>
@@ -2931,8 +2931,8 @@
         </p:nvSpPr>
         <p:spPr>
           <a:xfrm>
-            <a:off x="5879592" y="4754880"/>
-            <a:ext cx="5394960" cy="1325880"/>
+            <a:off x="914400" y="4754880"/>
+            <a:ext cx="9171432" cy="1325880"/>
           </a:xfrm>
           <a:prstGeom prst="rect">
             <a:avLst/>
@@ -2990,113 +2990,6 @@
               <a:t>בישראל אינו גדל בר: כל השיחים ניטעו בגינות, בגדרות חיות וברחובות</a:t>
             </a:r>
             <a:endParaRPr lang="en-US" sz="1450" dirty="0"/>
-          </a:p>
-        </p:txBody>
-      </p:sp>
-      <p:sp>
-        <p:nvSpPr>
-          <p:cNvPr id="17" name="Shape 13"/>
-          <p:cNvSpPr/>
-          <p:nvPr/>
-        </p:nvSpPr>
-        <p:spPr>
-          <a:xfrm>
-            <a:off x="594360" y="1737360"/>
-            <a:ext cx="4709160" cy="4480560"/>
-          </a:xfrm>
-          <a:prstGeom prst="roundRect">
-            <a:avLst>
-              <a:gd name="adj" fmla="val 2449"/>
-            </a:avLst>
-          </a:prstGeom>
-          <a:solidFill>
-            <a:srgbClr val="FAFBF7"/>
-          </a:solidFill>
-          <a:ln w="19050">
-            <a:solidFill>
-              <a:srgbClr val="97BC62"/>
-            </a:solidFill>
-            <a:prstDash val="dash"/>
-          </a:ln>
-        </p:spPr>
-      </p:sp>
-      <p:pic>
-        <p:nvPicPr>
-          <p:cNvPr id="18" name="Image 2" descr="preencoded.png">    </p:cNvPr>
-          <p:cNvPicPr>
-            <a:picLocks noChangeAspect="1"/>
-          </p:cNvPicPr>
-          <p:nvPr/>
-        </p:nvPicPr>
-        <p:blipFill>
-          <a:blip r:embed="rId3"/>
-          <a:stretch>
-            <a:fillRect/>
-          </a:stretch>
-        </p:blipFill>
-        <p:spPr>
-          <a:xfrm>
-            <a:off x="2628900" y="3429000"/>
-            <a:ext cx="640080" cy="640080"/>
-          </a:xfrm>
-          <a:prstGeom prst="rect">
-            <a:avLst/>
-          </a:prstGeom>
-        </p:spPr>
-      </p:pic>
-      <p:sp>
-        <p:nvSpPr>
-          <p:cNvPr id="19" name="Text 14"/>
-          <p:cNvSpPr/>
-          <p:nvPr/>
-        </p:nvSpPr>
-        <p:spPr>
-          <a:xfrm>
-            <a:off x="777240" y="4114800"/>
-            <a:ext cx="4343400" cy="731520"/>
-          </a:xfrm>
-          <a:prstGeom prst="rect">
-            <a:avLst/>
-          </a:prstGeom>
-          <a:noFill/>
-          <a:ln/>
-        </p:spPr>
-        <p:txBody>
-          <a:bodyPr wrap="square" lIns="0" tIns="0" rIns="0" bIns="0" rtlCol="0" anchor="ctr"/>
-          <a:lstStyle/>
-          <a:p>
-            <a:pPr rtl="1" algn="ctr" indent="0" marL="0">
-              <a:buNone/>
-            </a:pPr>
-            <a:r>
-              <a:rPr lang="en-US" sz="1150" dirty="0">
-                <a:solidFill>
-                  <a:srgbClr val="5F6E53"/>
-                </a:solidFill>
-                <a:latin typeface="Arial" pitchFamily="34" charset="0"/>
-                <a:ea typeface="Arial" pitchFamily="34" charset="-122"/>
-                <a:cs typeface="Arial" pitchFamily="34" charset="-120"/>
-              </a:rPr>
-              <a:t>כאן צילום שלכם: השיח בסביבתו</a:t>
-            </a:r>
-            <a:endParaRPr lang="en-US" sz="1150" dirty="0"/>
-          </a:p>
-          <a:p>
-            <a:pPr rtl="1" algn="ctr" indent="0" marL="0">
-              <a:buNone/>
-            </a:pPr>
-            <a:r>
-              <a:rPr lang="en-US" sz="1150" dirty="0">
-                <a:solidFill>
-                  <a:srgbClr val="5F6E53"/>
-                </a:solidFill>
-                <a:latin typeface="Arial" pitchFamily="34" charset="0"/>
-                <a:ea typeface="Arial" pitchFamily="34" charset="-122"/>
-                <a:cs typeface="Arial" pitchFamily="34" charset="-120"/>
-              </a:rPr>
-              <a:t>(גינה, גדר חיה או רחוב)</a:t>
-            </a:r>
-            <a:endParaRPr lang="en-US" sz="1150" dirty="0"/>
           </a:p>
         </p:txBody>
       </p:sp>
@@ -8933,8 +8826,8 @@
         </p:nvSpPr>
         <p:spPr>
           <a:xfrm>
-            <a:off x="5559552" y="1783080"/>
-            <a:ext cx="6035040" cy="786384"/>
+            <a:off x="1522476" y="1783080"/>
+            <a:ext cx="9144000" cy="786384"/>
           </a:xfrm>
           <a:prstGeom prst="roundRect">
             <a:avLst>
@@ -8955,8 +8848,8 @@
         </p:nvSpPr>
         <p:spPr>
           <a:xfrm>
-            <a:off x="9994392" y="1783080"/>
-            <a:ext cx="1417320" cy="786384"/>
+            <a:off x="8700516" y="1783080"/>
+            <a:ext cx="1737360" cy="786384"/>
           </a:xfrm>
           <a:prstGeom prst="rect">
             <a:avLst/>
@@ -8972,7 +8865,7 @@
               <a:buNone/>
             </a:pPr>
             <a:r>
-              <a:rPr lang="en-US" sz="1400" b="1" dirty="0">
+              <a:rPr lang="en-US" sz="1450" b="1" dirty="0">
                 <a:solidFill>
                   <a:srgbClr val="2F6B5C"/>
                 </a:solidFill>
@@ -8982,7 +8875,7 @@
               </a:rPr>
               <a:t>ממלכה</a:t>
             </a:r>
-            <a:endParaRPr lang="en-US" sz="1400" dirty="0"/>
+            <a:endParaRPr lang="en-US" sz="1450" dirty="0"/>
           </a:p>
         </p:txBody>
       </p:sp>
@@ -8994,8 +8887,8 @@
         </p:nvSpPr>
         <p:spPr>
           <a:xfrm>
-            <a:off x="5788152" y="1783080"/>
-            <a:ext cx="4114800" cy="786384"/>
+            <a:off x="1796796" y="1783080"/>
+            <a:ext cx="6766560" cy="786384"/>
           </a:xfrm>
           <a:prstGeom prst="rect">
             <a:avLst/>
@@ -9011,7 +8904,7 @@
               <a:buNone/>
             </a:pPr>
             <a:r>
-              <a:rPr lang="en-US" sz="1350" dirty="0">
+              <a:rPr lang="en-US" sz="1400" dirty="0">
                 <a:solidFill>
                   <a:srgbClr val="26331F"/>
                 </a:solidFill>
@@ -9021,7 +8914,7 @@
               </a:rPr>
               <a:t>הצמחים</a:t>
             </a:r>
-            <a:endParaRPr lang="en-US" sz="1350" dirty="0"/>
+            <a:endParaRPr lang="en-US" sz="1400" dirty="0"/>
           </a:p>
         </p:txBody>
       </p:sp>
@@ -9033,8 +8926,8 @@
         </p:nvSpPr>
         <p:spPr>
           <a:xfrm>
-            <a:off x="5559552" y="2697480"/>
-            <a:ext cx="6035040" cy="786384"/>
+            <a:off x="1522476" y="2697480"/>
+            <a:ext cx="9144000" cy="786384"/>
           </a:xfrm>
           <a:prstGeom prst="roundRect">
             <a:avLst>
@@ -9055,8 +8948,8 @@
         </p:nvSpPr>
         <p:spPr>
           <a:xfrm>
-            <a:off x="9994392" y="2697480"/>
-            <a:ext cx="1417320" cy="786384"/>
+            <a:off x="8700516" y="2697480"/>
+            <a:ext cx="1737360" cy="786384"/>
           </a:xfrm>
           <a:prstGeom prst="rect">
             <a:avLst/>
@@ -9072,7 +8965,7 @@
               <a:buNone/>
             </a:pPr>
             <a:r>
-              <a:rPr lang="en-US" sz="1400" b="1" dirty="0">
+              <a:rPr lang="en-US" sz="1450" b="1" dirty="0">
                 <a:solidFill>
                   <a:srgbClr val="2F6B5C"/>
                 </a:solidFill>
@@ -9082,7 +8975,7 @@
               </a:rPr>
               <a:t>קבוצה</a:t>
             </a:r>
-            <a:endParaRPr lang="en-US" sz="1400" dirty="0"/>
+            <a:endParaRPr lang="en-US" sz="1450" dirty="0"/>
           </a:p>
         </p:txBody>
       </p:sp>
@@ -9094,8 +8987,8 @@
         </p:nvSpPr>
         <p:spPr>
           <a:xfrm>
-            <a:off x="5788152" y="2697480"/>
-            <a:ext cx="4114800" cy="786384"/>
+            <a:off x="1796796" y="2697480"/>
+            <a:ext cx="6766560" cy="786384"/>
           </a:xfrm>
           <a:prstGeom prst="rect">
             <a:avLst/>
@@ -9111,7 +9004,7 @@
               <a:buNone/>
             </a:pPr>
             <a:r>
-              <a:rPr lang="en-US" sz="1350" dirty="0">
+              <a:rPr lang="en-US" sz="1400" dirty="0">
                 <a:solidFill>
                   <a:srgbClr val="26331F"/>
                 </a:solidFill>
@@ -9121,7 +9014,7 @@
               </a:rPr>
               <a:t>צמחים בעלי זרעים: חשופי זרע (מחטניים)</a:t>
             </a:r>
-            <a:endParaRPr lang="en-US" sz="1350" dirty="0"/>
+            <a:endParaRPr lang="en-US" sz="1400" dirty="0"/>
           </a:p>
         </p:txBody>
       </p:sp>
@@ -9133,8 +9026,8 @@
         </p:nvSpPr>
         <p:spPr>
           <a:xfrm>
-            <a:off x="5559552" y="3611880"/>
-            <a:ext cx="6035040" cy="786384"/>
+            <a:off x="1522476" y="3611880"/>
+            <a:ext cx="9144000" cy="786384"/>
           </a:xfrm>
           <a:prstGeom prst="roundRect">
             <a:avLst>
@@ -9155,8 +9048,8 @@
         </p:nvSpPr>
         <p:spPr>
           <a:xfrm>
-            <a:off x="9994392" y="3611880"/>
-            <a:ext cx="1417320" cy="786384"/>
+            <a:off x="8700516" y="3611880"/>
+            <a:ext cx="1737360" cy="786384"/>
           </a:xfrm>
           <a:prstGeom prst="rect">
             <a:avLst/>
@@ -9172,7 +9065,7 @@
               <a:buNone/>
             </a:pPr>
             <a:r>
-              <a:rPr lang="en-US" sz="1400" b="1" dirty="0">
+              <a:rPr lang="en-US" sz="1450" b="1" dirty="0">
                 <a:solidFill>
                   <a:srgbClr val="2F6B5C"/>
                 </a:solidFill>
@@ -9182,7 +9075,7 @@
               </a:rPr>
               <a:t>משפחה</a:t>
             </a:r>
-            <a:endParaRPr lang="en-US" sz="1400" dirty="0"/>
+            <a:endParaRPr lang="en-US" sz="1450" dirty="0"/>
           </a:p>
         </p:txBody>
       </p:sp>
@@ -9194,8 +9087,8 @@
         </p:nvSpPr>
         <p:spPr>
           <a:xfrm>
-            <a:off x="5788152" y="3611880"/>
-            <a:ext cx="4114800" cy="786384"/>
+            <a:off x="1796796" y="3611880"/>
+            <a:ext cx="6766560" cy="786384"/>
           </a:xfrm>
           <a:prstGeom prst="rect">
             <a:avLst/>
@@ -9211,7 +9104,7 @@
               <a:buNone/>
             </a:pPr>
             <a:r>
-              <a:rPr lang="en-US" sz="1350" dirty="0">
+              <a:rPr lang="en-US" sz="1400" dirty="0">
                 <a:solidFill>
                   <a:srgbClr val="26331F"/>
                 </a:solidFill>
@@ -9221,7 +9114,7 @@
               </a:rPr>
               <a:t>אורניים (Pinaceae)</a:t>
             </a:r>
-            <a:endParaRPr lang="en-US" sz="1350" dirty="0"/>
+            <a:endParaRPr lang="en-US" sz="1400" dirty="0"/>
           </a:p>
         </p:txBody>
       </p:sp>
@@ -9233,8 +9126,8 @@
         </p:nvSpPr>
         <p:spPr>
           <a:xfrm>
-            <a:off x="5559552" y="4526280"/>
-            <a:ext cx="6035040" cy="786384"/>
+            <a:off x="1522476" y="4526280"/>
+            <a:ext cx="9144000" cy="786384"/>
           </a:xfrm>
           <a:prstGeom prst="roundRect">
             <a:avLst>
@@ -9255,8 +9148,8 @@
         </p:nvSpPr>
         <p:spPr>
           <a:xfrm>
-            <a:off x="9994392" y="4526280"/>
-            <a:ext cx="1417320" cy="786384"/>
+            <a:off x="8700516" y="4526280"/>
+            <a:ext cx="1737360" cy="786384"/>
           </a:xfrm>
           <a:prstGeom prst="rect">
             <a:avLst/>
@@ -9272,7 +9165,7 @@
               <a:buNone/>
             </a:pPr>
             <a:r>
-              <a:rPr lang="en-US" sz="1400" b="1" dirty="0">
+              <a:rPr lang="en-US" sz="1450" b="1" dirty="0">
                 <a:solidFill>
                   <a:srgbClr val="2F6B5C"/>
                 </a:solidFill>
@@ -9282,7 +9175,7 @@
               </a:rPr>
               <a:t>סוג</a:t>
             </a:r>
-            <a:endParaRPr lang="en-US" sz="1400" dirty="0"/>
+            <a:endParaRPr lang="en-US" sz="1450" dirty="0"/>
           </a:p>
         </p:txBody>
       </p:sp>
@@ -9294,8 +9187,8 @@
         </p:nvSpPr>
         <p:spPr>
           <a:xfrm>
-            <a:off x="5788152" y="4526280"/>
-            <a:ext cx="4114800" cy="786384"/>
+            <a:off x="1796796" y="4526280"/>
+            <a:ext cx="6766560" cy="786384"/>
           </a:xfrm>
           <a:prstGeom prst="rect">
             <a:avLst/>
@@ -9311,7 +9204,7 @@
               <a:buNone/>
             </a:pPr>
             <a:r>
-              <a:rPr lang="en-US" sz="1350" dirty="0">
+              <a:rPr lang="en-US" sz="1400" dirty="0">
                 <a:solidFill>
                   <a:srgbClr val="26331F"/>
                 </a:solidFill>
@@ -9321,7 +9214,7 @@
               </a:rPr>
               <a:t>אורן (Pinus)</a:t>
             </a:r>
-            <a:endParaRPr lang="en-US" sz="1350" dirty="0"/>
+            <a:endParaRPr lang="en-US" sz="1400" dirty="0"/>
           </a:p>
         </p:txBody>
       </p:sp>
@@ -9333,8 +9226,8 @@
         </p:nvSpPr>
         <p:spPr>
           <a:xfrm>
-            <a:off x="5559552" y="5440680"/>
-            <a:ext cx="6035040" cy="786384"/>
+            <a:off x="1522476" y="5440680"/>
+            <a:ext cx="9144000" cy="786384"/>
           </a:xfrm>
           <a:prstGeom prst="roundRect">
             <a:avLst>
@@ -9355,8 +9248,8 @@
         </p:nvSpPr>
         <p:spPr>
           <a:xfrm>
-            <a:off x="9994392" y="5440680"/>
-            <a:ext cx="1417320" cy="786384"/>
+            <a:off x="8700516" y="5440680"/>
+            <a:ext cx="1737360" cy="786384"/>
           </a:xfrm>
           <a:prstGeom prst="rect">
             <a:avLst/>
@@ -9372,7 +9265,7 @@
               <a:buNone/>
             </a:pPr>
             <a:r>
-              <a:rPr lang="en-US" sz="1400" b="1" dirty="0">
+              <a:rPr lang="en-US" sz="1450" b="1" dirty="0">
                 <a:solidFill>
                   <a:srgbClr val="2F6B5C"/>
                 </a:solidFill>
@@ -9382,7 +9275,7 @@
               </a:rPr>
               <a:t>מין</a:t>
             </a:r>
-            <a:endParaRPr lang="en-US" sz="1400" dirty="0"/>
+            <a:endParaRPr lang="en-US" sz="1450" dirty="0"/>
           </a:p>
         </p:txBody>
       </p:sp>
@@ -9394,8 +9287,8 @@
         </p:nvSpPr>
         <p:spPr>
           <a:xfrm>
-            <a:off x="5788152" y="5440680"/>
-            <a:ext cx="4114800" cy="786384"/>
+            <a:off x="1796796" y="5440680"/>
+            <a:ext cx="6766560" cy="786384"/>
           </a:xfrm>
           <a:prstGeom prst="rect">
             <a:avLst/>
@@ -9411,7 +9304,7 @@
               <a:buNone/>
             </a:pPr>
             <a:r>
-              <a:rPr lang="en-US" sz="1350" dirty="0">
+              <a:rPr lang="en-US" sz="1400" dirty="0">
                 <a:solidFill>
                   <a:srgbClr val="26331F"/>
                 </a:solidFill>
@@ -9421,114 +9314,7 @@
               </a:rPr>
               <a:t>אורן ירושלים (Pinus halepensis)</a:t>
             </a:r>
-            <a:endParaRPr lang="en-US" sz="1350" dirty="0"/>
-          </a:p>
-        </p:txBody>
-      </p:sp>
-      <p:sp>
-        <p:nvSpPr>
-          <p:cNvPr id="22" name="Shape 20"/>
-          <p:cNvSpPr/>
-          <p:nvPr/>
-        </p:nvSpPr>
-        <p:spPr>
-          <a:xfrm>
-            <a:off x="594360" y="1783080"/>
-            <a:ext cx="4892040" cy="4434840"/>
-          </a:xfrm>
-          <a:prstGeom prst="roundRect">
-            <a:avLst>
-              <a:gd name="adj" fmla="val 2474"/>
-            </a:avLst>
-          </a:prstGeom>
-          <a:solidFill>
-            <a:srgbClr val="FAFBF7"/>
-          </a:solidFill>
-          <a:ln w="19050">
-            <a:solidFill>
-              <a:srgbClr val="97BC62"/>
-            </a:solidFill>
-            <a:prstDash val="dash"/>
-          </a:ln>
-        </p:spPr>
-      </p:sp>
-      <p:pic>
-        <p:nvPicPr>
-          <p:cNvPr id="23" name="Image 0" descr="preencoded.png">    </p:cNvPr>
-          <p:cNvPicPr>
-            <a:picLocks noChangeAspect="1"/>
-          </p:cNvPicPr>
-          <p:nvPr/>
-        </p:nvPicPr>
-        <p:blipFill>
-          <a:blip r:embed="rId1"/>
-          <a:stretch>
-            <a:fillRect/>
-          </a:stretch>
-        </p:blipFill>
-        <p:spPr>
-          <a:xfrm>
-            <a:off x="2720340" y="3451860"/>
-            <a:ext cx="640080" cy="640080"/>
-          </a:xfrm>
-          <a:prstGeom prst="rect">
-            <a:avLst/>
-          </a:prstGeom>
-        </p:spPr>
-      </p:pic>
-      <p:sp>
-        <p:nvSpPr>
-          <p:cNvPr id="24" name="Text 21"/>
-          <p:cNvSpPr/>
-          <p:nvPr/>
-        </p:nvSpPr>
-        <p:spPr>
-          <a:xfrm>
-            <a:off x="777240" y="4137660"/>
-            <a:ext cx="4526280" cy="731520"/>
-          </a:xfrm>
-          <a:prstGeom prst="rect">
-            <a:avLst/>
-          </a:prstGeom>
-          <a:noFill/>
-          <a:ln/>
-        </p:spPr>
-        <p:txBody>
-          <a:bodyPr wrap="square" lIns="0" tIns="0" rIns="0" bIns="0" rtlCol="0" anchor="ctr"/>
-          <a:lstStyle/>
-          <a:p>
-            <a:pPr rtl="1" algn="ctr" indent="0" marL="0">
-              <a:buNone/>
-            </a:pPr>
-            <a:r>
-              <a:rPr lang="en-US" sz="1150" dirty="0">
-                <a:solidFill>
-                  <a:srgbClr val="5F6E53"/>
-                </a:solidFill>
-                <a:latin typeface="Arial" pitchFamily="34" charset="0"/>
-                <a:ea typeface="Arial" pitchFamily="34" charset="-122"/>
-                <a:cs typeface="Arial" pitchFamily="34" charset="-120"/>
-              </a:rPr>
-              <a:t>כאן תמונה או צילום וידאו שלכם ליד העץ:</a:t>
-            </a:r>
-            <a:endParaRPr lang="en-US" sz="1150" dirty="0"/>
-          </a:p>
-          <a:p>
-            <a:pPr rtl="1" algn="ctr" indent="0" marL="0">
-              <a:buNone/>
-            </a:pPr>
-            <a:r>
-              <a:rPr lang="en-US" sz="1150" dirty="0">
-                <a:solidFill>
-                  <a:srgbClr val="5F6E53"/>
-                </a:solidFill>
-                <a:latin typeface="Arial" pitchFamily="34" charset="0"/>
-                <a:ea typeface="Arial" pitchFamily="34" charset="-122"/>
-                <a:cs typeface="Arial" pitchFamily="34" charset="-120"/>
-              </a:rPr>
-              <a:t>מראה כללי של אורן ירושלים באזור המגורים</a:t>
-            </a:r>
-            <a:endParaRPr lang="en-US" sz="1150" dirty="0"/>
+            <a:endParaRPr lang="en-US" sz="1400" dirty="0"/>
           </a:p>
         </p:txBody>
       </p:sp>
@@ -10057,30 +9843,6 @@
             </a:r>
             <a:endParaRPr lang="en-US" sz="1450" dirty="0"/>
           </a:p>
-          <a:p>
-            <a:pPr algn="r" marL="152400" indent="-152400">
-              <a:lnSpc>
-                <a:spcPct val="108000"/>
-              </a:lnSpc>
-              <a:spcAft>
-                <a:spcPts val="800"/>
-              </a:spcAft>
-              <a:buSzPct val="100000"/>
-              <a:buChar char="•"/>
-            </a:pPr>
-            <a:r>
-              <a:rPr lang="en-US" sz="1450" dirty="0">
-                <a:solidFill>
-                  <a:srgbClr val="26331F"/>
-                </a:solidFill>
-                <a:latin typeface="Arial" pitchFamily="34" charset="0"/>
-                <a:ea typeface="Arial" pitchFamily="34" charset="-122"/>
-                <a:cs typeface="Arial" pitchFamily="34" charset="-120"/>
-              </a:rPr>
-              <a:t>בשקף זה כדאי לצלם מקרוב: מחטים, אצטרובל צעיר ואצטרובל בוגר</a:t>
-            </a:r>
-            <a:endParaRPr lang="en-US" sz="1450" dirty="0"/>
-          </a:p>
         </p:txBody>
       </p:sp>
     </p:spTree>
@@ -10284,8 +10046,8 @@
         </p:nvSpPr>
         <p:spPr>
           <a:xfrm>
-            <a:off x="5559552" y="1737360"/>
-            <a:ext cx="6035040" cy="2103120"/>
+            <a:off x="594360" y="1737360"/>
+            <a:ext cx="11000232" cy="2103120"/>
           </a:xfrm>
           <a:prstGeom prst="roundRect">
             <a:avLst>
@@ -10350,8 +10112,8 @@
         </p:nvSpPr>
         <p:spPr>
           <a:xfrm>
-            <a:off x="5879592" y="1965960"/>
-            <a:ext cx="4663440" cy="411480"/>
+            <a:off x="914400" y="1965960"/>
+            <a:ext cx="9628632" cy="411480"/>
           </a:xfrm>
           <a:prstGeom prst="rect">
             <a:avLst/>
@@ -10389,8 +10151,8 @@
         </p:nvSpPr>
         <p:spPr>
           <a:xfrm>
-            <a:off x="5879592" y="2423160"/>
-            <a:ext cx="5394960" cy="1280160"/>
+            <a:off x="914400" y="2423160"/>
+            <a:ext cx="9171432" cy="1280160"/>
           </a:xfrm>
           <a:prstGeom prst="rect">
             <a:avLst/>
@@ -10459,8 +10221,8 @@
         </p:nvSpPr>
         <p:spPr>
           <a:xfrm>
-            <a:off x="5559552" y="4069080"/>
-            <a:ext cx="6035040" cy="2103120"/>
+            <a:off x="594360" y="4069080"/>
+            <a:ext cx="11000232" cy="2103120"/>
           </a:xfrm>
           <a:prstGeom prst="roundRect">
             <a:avLst>
@@ -10525,8 +10287,8 @@
         </p:nvSpPr>
         <p:spPr>
           <a:xfrm>
-            <a:off x="5879592" y="4297680"/>
-            <a:ext cx="4663440" cy="411480"/>
+            <a:off x="914400" y="4297680"/>
+            <a:ext cx="9628632" cy="411480"/>
           </a:xfrm>
           <a:prstGeom prst="rect">
             <a:avLst/>
@@ -10564,8 +10326,8 @@
         </p:nvSpPr>
         <p:spPr>
           <a:xfrm>
-            <a:off x="5879592" y="4754880"/>
-            <a:ext cx="5394960" cy="1325880"/>
+            <a:off x="914400" y="4754880"/>
+            <a:ext cx="9171432" cy="1325880"/>
           </a:xfrm>
           <a:prstGeom prst="rect">
             <a:avLst/>
@@ -10623,113 +10385,6 @@
               <a:t>מהיערות הנטועים הוא מתפשט מאליו לשטחים פתוחים סמוכים</a:t>
             </a:r>
             <a:endParaRPr lang="en-US" sz="1450" dirty="0"/>
-          </a:p>
-        </p:txBody>
-      </p:sp>
-      <p:sp>
-        <p:nvSpPr>
-          <p:cNvPr id="17" name="Shape 13"/>
-          <p:cNvSpPr/>
-          <p:nvPr/>
-        </p:nvSpPr>
-        <p:spPr>
-          <a:xfrm>
-            <a:off x="594360" y="1737360"/>
-            <a:ext cx="4709160" cy="4480560"/>
-          </a:xfrm>
-          <a:prstGeom prst="roundRect">
-            <a:avLst>
-              <a:gd name="adj" fmla="val 2449"/>
-            </a:avLst>
-          </a:prstGeom>
-          <a:solidFill>
-            <a:srgbClr val="FAFBF7"/>
-          </a:solidFill>
-          <a:ln w="19050">
-            <a:solidFill>
-              <a:srgbClr val="97BC62"/>
-            </a:solidFill>
-            <a:prstDash val="dash"/>
-          </a:ln>
-        </p:spPr>
-      </p:sp>
-      <p:pic>
-        <p:nvPicPr>
-          <p:cNvPr id="18" name="Image 2" descr="preencoded.png">    </p:cNvPr>
-          <p:cNvPicPr>
-            <a:picLocks noChangeAspect="1"/>
-          </p:cNvPicPr>
-          <p:nvPr/>
-        </p:nvPicPr>
-        <p:blipFill>
-          <a:blip r:embed="rId3"/>
-          <a:stretch>
-            <a:fillRect/>
-          </a:stretch>
-        </p:blipFill>
-        <p:spPr>
-          <a:xfrm>
-            <a:off x="2628900" y="3429000"/>
-            <a:ext cx="640080" cy="640080"/>
-          </a:xfrm>
-          <a:prstGeom prst="rect">
-            <a:avLst/>
-          </a:prstGeom>
-        </p:spPr>
-      </p:pic>
-      <p:sp>
-        <p:nvSpPr>
-          <p:cNvPr id="19" name="Text 14"/>
-          <p:cNvSpPr/>
-          <p:nvPr/>
-        </p:nvSpPr>
-        <p:spPr>
-          <a:xfrm>
-            <a:off x="777240" y="4114800"/>
-            <a:ext cx="4343400" cy="731520"/>
-          </a:xfrm>
-          <a:prstGeom prst="rect">
-            <a:avLst/>
-          </a:prstGeom>
-          <a:noFill/>
-          <a:ln/>
-        </p:spPr>
-        <p:txBody>
-          <a:bodyPr wrap="square" lIns="0" tIns="0" rIns="0" bIns="0" rtlCol="0" anchor="ctr"/>
-          <a:lstStyle/>
-          <a:p>
-            <a:pPr rtl="1" algn="ctr" indent="0" marL="0">
-              <a:buNone/>
-            </a:pPr>
-            <a:r>
-              <a:rPr lang="en-US" sz="1150" dirty="0">
-                <a:solidFill>
-                  <a:srgbClr val="5F6E53"/>
-                </a:solidFill>
-                <a:latin typeface="Arial" pitchFamily="34" charset="0"/>
-                <a:ea typeface="Arial" pitchFamily="34" charset="-122"/>
-                <a:cs typeface="Arial" pitchFamily="34" charset="-120"/>
-              </a:rPr>
-              <a:t>כאן צילום שלכם: העץ בסביבתו</a:t>
-            </a:r>
-            <a:endParaRPr lang="en-US" sz="1150" dirty="0"/>
-          </a:p>
-          <a:p>
-            <a:pPr rtl="1" algn="ctr" indent="0" marL="0">
-              <a:buNone/>
-            </a:pPr>
-            <a:r>
-              <a:rPr lang="en-US" sz="1150" dirty="0">
-                <a:solidFill>
-                  <a:srgbClr val="5F6E53"/>
-                </a:solidFill>
-                <a:latin typeface="Arial" pitchFamily="34" charset="0"/>
-                <a:ea typeface="Arial" pitchFamily="34" charset="-122"/>
-                <a:cs typeface="Arial" pitchFamily="34" charset="-120"/>
-              </a:rPr>
-              <a:t>(חורש, יער נטוע או שכונה)</a:t>
-            </a:r>
-            <a:endParaRPr lang="en-US" sz="1150" dirty="0"/>
           </a:p>
         </p:txBody>
       </p:sp>

</xml_diff>